<commit_message>
Update Binary Search Tree Operations.pptx
</commit_message>
<xml_diff>
--- a/tree/Binary Search Tree Operations.pptx
+++ b/tree/Binary Search Tree Operations.pptx
@@ -8,9 +8,9 @@
     <p:notesMasterId r:id="rId35"/>
   </p:notesMasterIdLst>
   <p:sldIdLst>
-    <p:sldId id="341" r:id="rId5"/>
-    <p:sldId id="293" r:id="rId6"/>
-    <p:sldId id="343" r:id="rId7"/>
+    <p:sldId id="343" r:id="rId5"/>
+    <p:sldId id="341" r:id="rId6"/>
+    <p:sldId id="293" r:id="rId7"/>
     <p:sldId id="342" r:id="rId8"/>
     <p:sldId id="344" r:id="rId9"/>
     <p:sldId id="345" r:id="rId10"/>
@@ -510,7 +510,7 @@
         <p:cNvPr id="1" name="">
           <a:extLst>
             <a:ext uri="{FF2B5EF4-FFF2-40B4-BE49-F238E27FC236}">
-              <a16:creationId xmlns:a16="http://schemas.microsoft.com/office/drawing/2014/main" id="{E41E622F-8F92-218A-49E8-FEB827A128B5}"/>
+              <a16:creationId xmlns:a16="http://schemas.microsoft.com/office/drawing/2014/main" id="{F71B65ED-8251-D26B-73AD-ED38C8419A30}"/>
             </a:ext>
           </a:extLst>
         </p:cNvPr>
@@ -530,7 +530,7 @@
           <p:cNvPr id="2" name="Slide Image Placeholder 1">
             <a:extLst>
               <a:ext uri="{FF2B5EF4-FFF2-40B4-BE49-F238E27FC236}">
-                <a16:creationId xmlns:a16="http://schemas.microsoft.com/office/drawing/2014/main" id="{939627AF-0210-3562-C413-6C73E815943B}"/>
+                <a16:creationId xmlns:a16="http://schemas.microsoft.com/office/drawing/2014/main" id="{E2CFAC85-DD78-0957-B4AA-E52751FADE62}"/>
               </a:ext>
             </a:extLst>
           </p:cNvPr>
@@ -548,7 +548,7 @@
           <p:cNvPr id="3" name="Notes Placeholder 2">
             <a:extLst>
               <a:ext uri="{FF2B5EF4-FFF2-40B4-BE49-F238E27FC236}">
-                <a16:creationId xmlns:a16="http://schemas.microsoft.com/office/drawing/2014/main" id="{49F4A2BC-6C4D-0EA1-C911-C961C27BB48C}"/>
+                <a16:creationId xmlns:a16="http://schemas.microsoft.com/office/drawing/2014/main" id="{2AF7D08A-E6B7-F39D-639F-85B4A2637666}"/>
               </a:ext>
             </a:extLst>
           </p:cNvPr>
@@ -573,7 +573,7 @@
           <p:cNvPr id="4" name="Slide Number Placeholder 3">
             <a:extLst>
               <a:ext uri="{FF2B5EF4-FFF2-40B4-BE49-F238E27FC236}">
-                <a16:creationId xmlns:a16="http://schemas.microsoft.com/office/drawing/2014/main" id="{FFC9D646-D4E3-6AAF-AE86-0CBA31CEA311}"/>
+                <a16:creationId xmlns:a16="http://schemas.microsoft.com/office/drawing/2014/main" id="{F6A8C7A6-B800-3BD5-A0F1-6E9A277918F8}"/>
               </a:ext>
             </a:extLst>
           </p:cNvPr>
@@ -600,7 +600,7 @@
     </p:spTree>
     <p:extLst>
       <p:ext uri="{BB962C8B-B14F-4D97-AF65-F5344CB8AC3E}">
-        <p14:creationId xmlns:p14="http://schemas.microsoft.com/office/powerpoint/2010/main" val="2406316976"/>
+        <p14:creationId xmlns:p14="http://schemas.microsoft.com/office/powerpoint/2010/main" val="3646481246"/>
       </p:ext>
     </p:extLst>
   </p:cSld>
@@ -1695,7 +1695,13 @@
   <p:cSld>
     <p:spTree>
       <p:nvGrpSpPr>
-        <p:cNvPr id="1" name=""/>
+        <p:cNvPr id="1" name="">
+          <a:extLst>
+            <a:ext uri="{FF2B5EF4-FFF2-40B4-BE49-F238E27FC236}">
+              <a16:creationId xmlns:a16="http://schemas.microsoft.com/office/drawing/2014/main" id="{E41E622F-8F92-218A-49E8-FEB827A128B5}"/>
+            </a:ext>
+          </a:extLst>
+        </p:cNvPr>
         <p:cNvGrpSpPr/>
         <p:nvPr/>
       </p:nvGrpSpPr>
@@ -1709,7 +1715,13 @@
       </p:grpSpPr>
       <p:sp>
         <p:nvSpPr>
-          <p:cNvPr id="2" name="Slide Image Placeholder 1"/>
+          <p:cNvPr id="2" name="Slide Image Placeholder 1">
+            <a:extLst>
+              <a:ext uri="{FF2B5EF4-FFF2-40B4-BE49-F238E27FC236}">
+                <a16:creationId xmlns:a16="http://schemas.microsoft.com/office/drawing/2014/main" id="{939627AF-0210-3562-C413-6C73E815943B}"/>
+              </a:ext>
+            </a:extLst>
+          </p:cNvPr>
           <p:cNvSpPr>
             <a:spLocks noGrp="1" noRot="1" noChangeAspect="1"/>
           </p:cNvSpPr>
@@ -1721,7 +1733,13 @@
       </p:sp>
       <p:sp>
         <p:nvSpPr>
-          <p:cNvPr id="3" name="Notes Placeholder 2"/>
+          <p:cNvPr id="3" name="Notes Placeholder 2">
+            <a:extLst>
+              <a:ext uri="{FF2B5EF4-FFF2-40B4-BE49-F238E27FC236}">
+                <a16:creationId xmlns:a16="http://schemas.microsoft.com/office/drawing/2014/main" id="{49F4A2BC-6C4D-0EA1-C911-C961C27BB48C}"/>
+              </a:ext>
+            </a:extLst>
+          </p:cNvPr>
           <p:cNvSpPr>
             <a:spLocks noGrp="1"/>
           </p:cNvSpPr>
@@ -1740,7 +1758,13 @@
       </p:sp>
       <p:sp>
         <p:nvSpPr>
-          <p:cNvPr id="4" name="Slide Number Placeholder 3"/>
+          <p:cNvPr id="4" name="Slide Number Placeholder 3">
+            <a:extLst>
+              <a:ext uri="{FF2B5EF4-FFF2-40B4-BE49-F238E27FC236}">
+                <a16:creationId xmlns:a16="http://schemas.microsoft.com/office/drawing/2014/main" id="{FFC9D646-D4E3-6AAF-AE86-0CBA31CEA311}"/>
+              </a:ext>
+            </a:extLst>
+          </p:cNvPr>
           <p:cNvSpPr>
             <a:spLocks noGrp="1"/>
           </p:cNvSpPr>
@@ -1764,7 +1788,7 @@
     </p:spTree>
     <p:extLst>
       <p:ext uri="{BB962C8B-B14F-4D97-AF65-F5344CB8AC3E}">
-        <p14:creationId xmlns:p14="http://schemas.microsoft.com/office/powerpoint/2010/main" val="1347457313"/>
+        <p14:creationId xmlns:p14="http://schemas.microsoft.com/office/powerpoint/2010/main" val="2406316976"/>
       </p:ext>
     </p:extLst>
   </p:cSld>
@@ -2859,13 +2883,7 @@
   <p:cSld>
     <p:spTree>
       <p:nvGrpSpPr>
-        <p:cNvPr id="1" name="">
-          <a:extLst>
-            <a:ext uri="{FF2B5EF4-FFF2-40B4-BE49-F238E27FC236}">
-              <a16:creationId xmlns:a16="http://schemas.microsoft.com/office/drawing/2014/main" id="{F71B65ED-8251-D26B-73AD-ED38C8419A30}"/>
-            </a:ext>
-          </a:extLst>
-        </p:cNvPr>
+        <p:cNvPr id="1" name=""/>
         <p:cNvGrpSpPr/>
         <p:nvPr/>
       </p:nvGrpSpPr>
@@ -2879,13 +2897,7 @@
       </p:grpSpPr>
       <p:sp>
         <p:nvSpPr>
-          <p:cNvPr id="2" name="Slide Image Placeholder 1">
-            <a:extLst>
-              <a:ext uri="{FF2B5EF4-FFF2-40B4-BE49-F238E27FC236}">
-                <a16:creationId xmlns:a16="http://schemas.microsoft.com/office/drawing/2014/main" id="{E2CFAC85-DD78-0957-B4AA-E52751FADE62}"/>
-              </a:ext>
-            </a:extLst>
-          </p:cNvPr>
+          <p:cNvPr id="2" name="Slide Image Placeholder 1"/>
           <p:cNvSpPr>
             <a:spLocks noGrp="1" noRot="1" noChangeAspect="1"/>
           </p:cNvSpPr>
@@ -2897,13 +2909,7 @@
       </p:sp>
       <p:sp>
         <p:nvSpPr>
-          <p:cNvPr id="3" name="Notes Placeholder 2">
-            <a:extLst>
-              <a:ext uri="{FF2B5EF4-FFF2-40B4-BE49-F238E27FC236}">
-                <a16:creationId xmlns:a16="http://schemas.microsoft.com/office/drawing/2014/main" id="{2AF7D08A-E6B7-F39D-639F-85B4A2637666}"/>
-              </a:ext>
-            </a:extLst>
-          </p:cNvPr>
+          <p:cNvPr id="3" name="Notes Placeholder 2"/>
           <p:cNvSpPr>
             <a:spLocks noGrp="1"/>
           </p:cNvSpPr>
@@ -2922,13 +2928,7 @@
       </p:sp>
       <p:sp>
         <p:nvSpPr>
-          <p:cNvPr id="4" name="Slide Number Placeholder 3">
-            <a:extLst>
-              <a:ext uri="{FF2B5EF4-FFF2-40B4-BE49-F238E27FC236}">
-                <a16:creationId xmlns:a16="http://schemas.microsoft.com/office/drawing/2014/main" id="{F6A8C7A6-B800-3BD5-A0F1-6E9A277918F8}"/>
-              </a:ext>
-            </a:extLst>
-          </p:cNvPr>
+          <p:cNvPr id="4" name="Slide Number Placeholder 3"/>
           <p:cNvSpPr>
             <a:spLocks noGrp="1"/>
           </p:cNvSpPr>
@@ -2952,7 +2952,7 @@
     </p:spTree>
     <p:extLst>
       <p:ext uri="{BB962C8B-B14F-4D97-AF65-F5344CB8AC3E}">
-        <p14:creationId xmlns:p14="http://schemas.microsoft.com/office/powerpoint/2010/main" val="3646481246"/>
+        <p14:creationId xmlns:p14="http://schemas.microsoft.com/office/powerpoint/2010/main" val="1347457313"/>
       </p:ext>
     </p:extLst>
   </p:cSld>
@@ -6952,7 +6952,7 @@
         <p:cNvPr id="1" name="">
           <a:extLst>
             <a:ext uri="{FF2B5EF4-FFF2-40B4-BE49-F238E27FC236}">
-              <a16:creationId xmlns:a16="http://schemas.microsoft.com/office/drawing/2014/main" id="{205744AF-DA71-F5F9-36A7-5CDC1EB6E59B}"/>
+              <a16:creationId xmlns:a16="http://schemas.microsoft.com/office/drawing/2014/main" id="{2774B763-0D9B-5461-69C0-39C704F058B8}"/>
             </a:ext>
           </a:extLst>
         </p:cNvPr>
@@ -6972,7 +6972,7 @@
           <p:cNvPr id="5" name="Title 1">
             <a:extLst>
               <a:ext uri="{FF2B5EF4-FFF2-40B4-BE49-F238E27FC236}">
-                <a16:creationId xmlns:a16="http://schemas.microsoft.com/office/drawing/2014/main" id="{71AEDA62-094B-FBBE-E395-382117D81280}"/>
+                <a16:creationId xmlns:a16="http://schemas.microsoft.com/office/drawing/2014/main" id="{36451F85-7493-B35F-FDBC-644A3480A778}"/>
               </a:ext>
             </a:extLst>
           </p:cNvPr>
@@ -6996,11 +6996,10 @@
           <a:lstStyle/>
           <a:p>
             <a:r>
-              <a:rPr lang="en-US" sz="6000" b="1" i="0" dirty="0" err="1">
+              <a:rPr lang="en-US" b="1" dirty="0" err="1">
                 <a:solidFill>
                   <a:srgbClr val="00B050"/>
                 </a:solidFill>
-                <a:effectLst/>
               </a:rPr>
               <a:t>TreeNode</a:t>
             </a:r>
@@ -7017,7 +7016,7 @@
           <p:cNvPr id="8" name="TextBox 7">
             <a:extLst>
               <a:ext uri="{FF2B5EF4-FFF2-40B4-BE49-F238E27FC236}">
-                <a16:creationId xmlns:a16="http://schemas.microsoft.com/office/drawing/2014/main" id="{D3F4B476-DFE7-1FC7-8408-B8101B2765C8}"/>
+                <a16:creationId xmlns:a16="http://schemas.microsoft.com/office/drawing/2014/main" id="{10888BF8-92F1-F7F7-8B9E-1754C6A0FA5B}"/>
               </a:ext>
             </a:extLst>
           </p:cNvPr>
@@ -7047,67 +7046,19 @@
                   <a:schemeClr val="bg1"/>
                 </a:solidFill>
               </a:rPr>
-              <a:t>Each node in a </a:t>
-            </a:r>
-            <a:r>
-              <a:rPr lang="en-PH" sz="2500" dirty="0">
+              <a:t>An implementation of a binary tree is a </a:t>
+            </a:r>
+            <a:r>
+              <a:rPr lang="en-PH" sz="2500" b="1" dirty="0">
                 <a:solidFill>
                   <a:srgbClr val="00B0F0"/>
                 </a:solidFill>
               </a:rPr>
-              <a:t>binary tree </a:t>
-            </a:r>
-            <a:r>
-              <a:rPr lang="en-PH" sz="2500" dirty="0">
-                <a:solidFill>
-                  <a:schemeClr val="bg1"/>
-                </a:solidFill>
-              </a:rPr>
-              <a:t>has a </a:t>
-            </a:r>
-            <a:r>
-              <a:rPr lang="en-PH" sz="2500" b="1" dirty="0">
-                <a:solidFill>
-                  <a:schemeClr val="bg1"/>
-                </a:solidFill>
-              </a:rPr>
-              <a:t>value</a:t>
-            </a:r>
-            <a:r>
-              <a:rPr lang="en-PH" sz="2500" dirty="0">
-                <a:solidFill>
-                  <a:schemeClr val="bg1"/>
-                </a:solidFill>
-              </a:rPr>
-              <a:t> and a </a:t>
-            </a:r>
-            <a:r>
-              <a:rPr lang="en-PH" sz="2500" b="1" dirty="0">
-                <a:solidFill>
-                  <a:schemeClr val="bg1"/>
-                </a:solidFill>
-              </a:rPr>
-              <a:t>left</a:t>
-            </a:r>
-            <a:r>
-              <a:rPr lang="en-PH" sz="2500" dirty="0">
-                <a:solidFill>
-                  <a:schemeClr val="bg1"/>
-                </a:solidFill>
-              </a:rPr>
-              <a:t> and </a:t>
-            </a:r>
-            <a:r>
-              <a:rPr lang="en-PH" sz="2500" b="1" dirty="0">
-                <a:solidFill>
-                  <a:schemeClr val="bg1"/>
-                </a:solidFill>
-              </a:rPr>
-              <a:t>right pointer</a:t>
+              <a:t>non-linear linked list</a:t>
             </a:r>
             <a:endParaRPr lang="en-US" sz="2500" b="1" dirty="0">
               <a:solidFill>
-                <a:schemeClr val="bg1"/>
+                <a:srgbClr val="00B0F0"/>
               </a:solidFill>
             </a:endParaRPr>
           </a:p>
@@ -7118,7 +7069,7 @@
           <p:cNvPr id="6" name="Rectangle 5">
             <a:extLst>
               <a:ext uri="{FF2B5EF4-FFF2-40B4-BE49-F238E27FC236}">
-                <a16:creationId xmlns:a16="http://schemas.microsoft.com/office/drawing/2014/main" id="{6F8B0BD4-8758-2596-64E8-953AD64BFB56}"/>
+                <a16:creationId xmlns:a16="http://schemas.microsoft.com/office/drawing/2014/main" id="{FFC5B58E-E56E-D5B2-F979-AEDABFE4EA4A}"/>
               </a:ext>
             </a:extLst>
           </p:cNvPr>
@@ -7127,8 +7078,8 @@
         </p:nvSpPr>
         <p:spPr>
           <a:xfrm>
-            <a:off x="5371142" y="2442714"/>
-            <a:ext cx="1800000" cy="1800000"/>
+            <a:off x="5614586" y="1636729"/>
+            <a:ext cx="540000" cy="540000"/>
           </a:xfrm>
           <a:prstGeom prst="rect">
             <a:avLst/>
@@ -7159,7 +7110,7 @@
           <a:p>
             <a:pPr algn="ctr"/>
             <a:r>
-              <a:rPr lang="en-US" sz="4000" b="1" dirty="0"/>
+              <a:rPr lang="en-US" sz="1200" b="1" dirty="0"/>
               <a:t>Value</a:t>
             </a:r>
           </a:p>
@@ -7170,7 +7121,7 @@
           <p:cNvPr id="3" name="Rectangle 2">
             <a:extLst>
               <a:ext uri="{FF2B5EF4-FFF2-40B4-BE49-F238E27FC236}">
-                <a16:creationId xmlns:a16="http://schemas.microsoft.com/office/drawing/2014/main" id="{B7FF0E3B-C7C8-30DC-7740-8DCD8C7847B3}"/>
+                <a16:creationId xmlns:a16="http://schemas.microsoft.com/office/drawing/2014/main" id="{FFCA009C-85B1-F720-27D3-4180E15A9C7B}"/>
               </a:ext>
             </a:extLst>
           </p:cNvPr>
@@ -7179,8 +7130,8 @@
         </p:nvSpPr>
         <p:spPr>
           <a:xfrm>
-            <a:off x="3571142" y="2442714"/>
-            <a:ext cx="1800000" cy="1800000"/>
+            <a:off x="5074586" y="1636729"/>
+            <a:ext cx="540000" cy="540000"/>
           </a:xfrm>
           <a:prstGeom prst="rect">
             <a:avLst/>
@@ -7213,7 +7164,7 @@
           <a:p>
             <a:pPr algn="ctr"/>
             <a:r>
-              <a:rPr lang="en-US" sz="4000" b="1" dirty="0"/>
+              <a:rPr lang="en-US" sz="900" b="1" dirty="0"/>
               <a:t>Left Pointer</a:t>
             </a:r>
           </a:p>
@@ -7224,7 +7175,7 @@
           <p:cNvPr id="4" name="Rectangle 3">
             <a:extLst>
               <a:ext uri="{FF2B5EF4-FFF2-40B4-BE49-F238E27FC236}">
-                <a16:creationId xmlns:a16="http://schemas.microsoft.com/office/drawing/2014/main" id="{783CBFDE-2FD0-BF4F-44D6-267789B39644}"/>
+                <a16:creationId xmlns:a16="http://schemas.microsoft.com/office/drawing/2014/main" id="{26F9F5DA-E232-EB49-B2CB-6A93CED76164}"/>
               </a:ext>
             </a:extLst>
           </p:cNvPr>
@@ -7233,8 +7184,8 @@
         </p:nvSpPr>
         <p:spPr>
           <a:xfrm>
-            <a:off x="7171142" y="2442714"/>
-            <a:ext cx="1800000" cy="1800000"/>
+            <a:off x="6132772" y="1636729"/>
+            <a:ext cx="540000" cy="540000"/>
           </a:xfrm>
           <a:prstGeom prst="rect">
             <a:avLst/>
@@ -7267,25 +7218,871 @@
           <a:p>
             <a:pPr algn="ctr"/>
             <a:r>
-              <a:rPr lang="en-US" sz="4000" b="1" dirty="0"/>
+              <a:rPr lang="en-US" sz="900" b="1" dirty="0"/>
               <a:t>Right</a:t>
             </a:r>
           </a:p>
           <a:p>
             <a:pPr algn="ctr"/>
             <a:r>
-              <a:rPr lang="en-US" sz="4000" b="1" dirty="0"/>
+              <a:rPr lang="en-US" sz="900" b="1" dirty="0"/>
               <a:t>Pointer</a:t>
             </a:r>
           </a:p>
         </p:txBody>
       </p:sp>
-      <p:sp>
-        <p:nvSpPr>
-          <p:cNvPr id="7" name="TextBox 6">
-            <a:extLst>
-              <a:ext uri="{FF2B5EF4-FFF2-40B4-BE49-F238E27FC236}">
-                <a16:creationId xmlns:a16="http://schemas.microsoft.com/office/drawing/2014/main" id="{DA88E708-C839-A39B-1DD4-CC6E910A2613}"/>
+      <p:cxnSp>
+        <p:nvCxnSpPr>
+          <p:cNvPr id="77" name="Straight Connector 76">
+            <a:extLst>
+              <a:ext uri="{FF2B5EF4-FFF2-40B4-BE49-F238E27FC236}">
+                <a16:creationId xmlns:a16="http://schemas.microsoft.com/office/drawing/2014/main" id="{78E187FB-5008-35C6-669F-25AAD7549486}"/>
+              </a:ext>
+            </a:extLst>
+          </p:cNvPr>
+          <p:cNvCxnSpPr>
+            <a:cxnSpLocks/>
+            <a:stCxn id="81" idx="0"/>
+          </p:cNvCxnSpPr>
+          <p:nvPr/>
+        </p:nvCxnSpPr>
+        <p:spPr>
+          <a:xfrm flipV="1">
+            <a:off x="4206001" y="2176729"/>
+            <a:ext cx="1138585" cy="689116"/>
+          </a:xfrm>
+          <a:prstGeom prst="line">
+            <a:avLst/>
+          </a:prstGeom>
+          <a:ln w="38100">
+            <a:solidFill>
+              <a:srgbClr val="AAAAAA"/>
+            </a:solidFill>
+          </a:ln>
+        </p:spPr>
+        <p:style>
+          <a:lnRef idx="1">
+            <a:schemeClr val="accent1"/>
+          </a:lnRef>
+          <a:fillRef idx="0">
+            <a:schemeClr val="accent1"/>
+          </a:fillRef>
+          <a:effectRef idx="0">
+            <a:schemeClr val="accent1"/>
+          </a:effectRef>
+          <a:fontRef idx="minor">
+            <a:schemeClr val="tx1"/>
+          </a:fontRef>
+        </p:style>
+      </p:cxnSp>
+      <p:cxnSp>
+        <p:nvCxnSpPr>
+          <p:cNvPr id="78" name="Straight Connector 77">
+            <a:extLst>
+              <a:ext uri="{FF2B5EF4-FFF2-40B4-BE49-F238E27FC236}">
+                <a16:creationId xmlns:a16="http://schemas.microsoft.com/office/drawing/2014/main" id="{119ADAB8-B729-A132-1024-46A974AED851}"/>
+              </a:ext>
+            </a:extLst>
+          </p:cNvPr>
+          <p:cNvCxnSpPr>
+            <a:cxnSpLocks/>
+            <a:stCxn id="84" idx="0"/>
+          </p:cNvCxnSpPr>
+          <p:nvPr/>
+        </p:nvCxnSpPr>
+        <p:spPr>
+          <a:xfrm flipH="1" flipV="1">
+            <a:off x="6402772" y="2176729"/>
+            <a:ext cx="1234441" cy="689116"/>
+          </a:xfrm>
+          <a:prstGeom prst="line">
+            <a:avLst/>
+          </a:prstGeom>
+          <a:ln w="38100">
+            <a:solidFill>
+              <a:srgbClr val="AAAAAA"/>
+            </a:solidFill>
+          </a:ln>
+        </p:spPr>
+        <p:style>
+          <a:lnRef idx="1">
+            <a:schemeClr val="accent1"/>
+          </a:lnRef>
+          <a:fillRef idx="0">
+            <a:schemeClr val="accent1"/>
+          </a:fillRef>
+          <a:effectRef idx="0">
+            <a:schemeClr val="accent1"/>
+          </a:effectRef>
+          <a:fontRef idx="minor">
+            <a:schemeClr val="tx1"/>
+          </a:fontRef>
+        </p:style>
+      </p:cxnSp>
+      <p:cxnSp>
+        <p:nvCxnSpPr>
+          <p:cNvPr id="79" name="Straight Connector 78">
+            <a:extLst>
+              <a:ext uri="{FF2B5EF4-FFF2-40B4-BE49-F238E27FC236}">
+                <a16:creationId xmlns:a16="http://schemas.microsoft.com/office/drawing/2014/main" id="{01689E5D-2681-B5D6-7D3D-681242ED8C10}"/>
+              </a:ext>
+            </a:extLst>
+          </p:cNvPr>
+          <p:cNvCxnSpPr>
+            <a:cxnSpLocks/>
+            <a:stCxn id="90" idx="0"/>
+            <a:endCxn id="88" idx="2"/>
+          </p:cNvCxnSpPr>
+          <p:nvPr/>
+        </p:nvCxnSpPr>
+        <p:spPr>
+          <a:xfrm flipV="1">
+            <a:off x="2884791" y="3405845"/>
+            <a:ext cx="769998" cy="420118"/>
+          </a:xfrm>
+          <a:prstGeom prst="line">
+            <a:avLst/>
+          </a:prstGeom>
+          <a:ln w="38100">
+            <a:solidFill>
+              <a:srgbClr val="AAAAAA"/>
+            </a:solidFill>
+          </a:ln>
+        </p:spPr>
+        <p:style>
+          <a:lnRef idx="1">
+            <a:schemeClr val="accent1"/>
+          </a:lnRef>
+          <a:fillRef idx="0">
+            <a:schemeClr val="accent1"/>
+          </a:fillRef>
+          <a:effectRef idx="0">
+            <a:schemeClr val="accent1"/>
+          </a:effectRef>
+          <a:fontRef idx="minor">
+            <a:schemeClr val="tx1"/>
+          </a:fontRef>
+        </p:style>
+      </p:cxnSp>
+      <p:cxnSp>
+        <p:nvCxnSpPr>
+          <p:cNvPr id="80" name="Straight Connector 79">
+            <a:extLst>
+              <a:ext uri="{FF2B5EF4-FFF2-40B4-BE49-F238E27FC236}">
+                <a16:creationId xmlns:a16="http://schemas.microsoft.com/office/drawing/2014/main" id="{2AA04C5F-E7F4-32AE-FC13-2EB4A200AE4D}"/>
+              </a:ext>
+            </a:extLst>
+          </p:cNvPr>
+          <p:cNvCxnSpPr>
+            <a:cxnSpLocks/>
+            <a:stCxn id="86" idx="2"/>
+            <a:endCxn id="87" idx="0"/>
+          </p:cNvCxnSpPr>
+          <p:nvPr/>
+        </p:nvCxnSpPr>
+        <p:spPr>
+          <a:xfrm>
+            <a:off x="8177213" y="3405845"/>
+            <a:ext cx="531771" cy="420118"/>
+          </a:xfrm>
+          <a:prstGeom prst="line">
+            <a:avLst/>
+          </a:prstGeom>
+          <a:ln w="38100">
+            <a:solidFill>
+              <a:srgbClr val="AAAAAA"/>
+            </a:solidFill>
+          </a:ln>
+        </p:spPr>
+        <p:style>
+          <a:lnRef idx="1">
+            <a:schemeClr val="accent1"/>
+          </a:lnRef>
+          <a:fillRef idx="0">
+            <a:schemeClr val="accent1"/>
+          </a:fillRef>
+          <a:effectRef idx="0">
+            <a:schemeClr val="accent1"/>
+          </a:effectRef>
+          <a:fontRef idx="minor">
+            <a:schemeClr val="tx1"/>
+          </a:fontRef>
+        </p:style>
+      </p:cxnSp>
+      <p:sp>
+        <p:nvSpPr>
+          <p:cNvPr id="81" name="Rectangle 80">
+            <a:extLst>
+              <a:ext uri="{FF2B5EF4-FFF2-40B4-BE49-F238E27FC236}">
+                <a16:creationId xmlns:a16="http://schemas.microsoft.com/office/drawing/2014/main" id="{7CE02771-8B46-D850-868D-AF850E6DC330}"/>
+              </a:ext>
+            </a:extLst>
+          </p:cNvPr>
+          <p:cNvSpPr/>
+          <p:nvPr/>
+        </p:nvSpPr>
+        <p:spPr>
+          <a:xfrm>
+            <a:off x="3936001" y="2865845"/>
+            <a:ext cx="540000" cy="540000"/>
+          </a:xfrm>
+          <a:prstGeom prst="rect">
+            <a:avLst/>
+          </a:prstGeom>
+          <a:solidFill>
+            <a:srgbClr val="6AB5FF"/>
+          </a:solidFill>
+        </p:spPr>
+        <p:style>
+          <a:lnRef idx="2">
+            <a:schemeClr val="accent1">
+              <a:shade val="15000"/>
+            </a:schemeClr>
+          </a:lnRef>
+          <a:fillRef idx="1">
+            <a:schemeClr val="accent1"/>
+          </a:fillRef>
+          <a:effectRef idx="0">
+            <a:schemeClr val="accent1"/>
+          </a:effectRef>
+          <a:fontRef idx="minor">
+            <a:schemeClr val="lt1"/>
+          </a:fontRef>
+        </p:style>
+        <p:txBody>
+          <a:bodyPr rtlCol="0" anchor="ctr"/>
+          <a:lstStyle/>
+          <a:p>
+            <a:pPr algn="ctr"/>
+            <a:r>
+              <a:rPr lang="en-US" sz="1200" b="1" dirty="0"/>
+              <a:t>Value</a:t>
+            </a:r>
+          </a:p>
+        </p:txBody>
+      </p:sp>
+      <p:sp>
+        <p:nvSpPr>
+          <p:cNvPr id="82" name="Rectangle 81">
+            <a:extLst>
+              <a:ext uri="{FF2B5EF4-FFF2-40B4-BE49-F238E27FC236}">
+                <a16:creationId xmlns:a16="http://schemas.microsoft.com/office/drawing/2014/main" id="{EA6B1BBB-CE61-A267-E9EB-0E6821F2AEE7}"/>
+              </a:ext>
+            </a:extLst>
+          </p:cNvPr>
+          <p:cNvSpPr/>
+          <p:nvPr/>
+        </p:nvSpPr>
+        <p:spPr>
+          <a:xfrm>
+            <a:off x="3390395" y="2865845"/>
+            <a:ext cx="540000" cy="540000"/>
+          </a:xfrm>
+          <a:prstGeom prst="rect">
+            <a:avLst/>
+          </a:prstGeom>
+          <a:solidFill>
+            <a:schemeClr val="accent5">
+              <a:lumMod val="50000"/>
+            </a:schemeClr>
+          </a:solidFill>
+        </p:spPr>
+        <p:style>
+          <a:lnRef idx="2">
+            <a:schemeClr val="accent1">
+              <a:shade val="15000"/>
+            </a:schemeClr>
+          </a:lnRef>
+          <a:fillRef idx="1">
+            <a:schemeClr val="accent1"/>
+          </a:fillRef>
+          <a:effectRef idx="0">
+            <a:schemeClr val="accent1"/>
+          </a:effectRef>
+          <a:fontRef idx="minor">
+            <a:schemeClr val="lt1"/>
+          </a:fontRef>
+        </p:style>
+        <p:txBody>
+          <a:bodyPr rtlCol="0" anchor="ctr"/>
+          <a:lstStyle/>
+          <a:p>
+            <a:pPr algn="ctr"/>
+            <a:r>
+              <a:rPr lang="en-US" sz="900" b="1" dirty="0"/>
+              <a:t>Left Pointer</a:t>
+            </a:r>
+          </a:p>
+        </p:txBody>
+      </p:sp>
+      <p:sp>
+        <p:nvSpPr>
+          <p:cNvPr id="83" name="Rectangle 82">
+            <a:extLst>
+              <a:ext uri="{FF2B5EF4-FFF2-40B4-BE49-F238E27FC236}">
+                <a16:creationId xmlns:a16="http://schemas.microsoft.com/office/drawing/2014/main" id="{6FB5394D-667B-9B98-CEF0-4067AAE74213}"/>
+              </a:ext>
+            </a:extLst>
+          </p:cNvPr>
+          <p:cNvSpPr/>
+          <p:nvPr/>
+        </p:nvSpPr>
+        <p:spPr>
+          <a:xfrm>
+            <a:off x="4476001" y="2865845"/>
+            <a:ext cx="540000" cy="540000"/>
+          </a:xfrm>
+          <a:prstGeom prst="rect">
+            <a:avLst/>
+          </a:prstGeom>
+          <a:solidFill>
+            <a:schemeClr val="accent5">
+              <a:lumMod val="50000"/>
+            </a:schemeClr>
+          </a:solidFill>
+        </p:spPr>
+        <p:style>
+          <a:lnRef idx="2">
+            <a:schemeClr val="accent1">
+              <a:shade val="15000"/>
+            </a:schemeClr>
+          </a:lnRef>
+          <a:fillRef idx="1">
+            <a:schemeClr val="accent1"/>
+          </a:fillRef>
+          <a:effectRef idx="0">
+            <a:schemeClr val="accent1"/>
+          </a:effectRef>
+          <a:fontRef idx="minor">
+            <a:schemeClr val="lt1"/>
+          </a:fontRef>
+        </p:style>
+        <p:txBody>
+          <a:bodyPr rtlCol="0" anchor="ctr"/>
+          <a:lstStyle/>
+          <a:p>
+            <a:pPr algn="ctr"/>
+            <a:r>
+              <a:rPr lang="en-US" sz="900" b="1" dirty="0"/>
+              <a:t>Right</a:t>
+            </a:r>
+          </a:p>
+          <a:p>
+            <a:pPr algn="ctr"/>
+            <a:r>
+              <a:rPr lang="en-US" sz="900" b="1" dirty="0"/>
+              <a:t>Pointer</a:t>
+            </a:r>
+          </a:p>
+        </p:txBody>
+      </p:sp>
+      <p:sp>
+        <p:nvSpPr>
+          <p:cNvPr id="84" name="Rectangle 83">
+            <a:extLst>
+              <a:ext uri="{FF2B5EF4-FFF2-40B4-BE49-F238E27FC236}">
+                <a16:creationId xmlns:a16="http://schemas.microsoft.com/office/drawing/2014/main" id="{8B4024BB-E862-81BB-61DD-2264DFA22725}"/>
+              </a:ext>
+            </a:extLst>
+          </p:cNvPr>
+          <p:cNvSpPr/>
+          <p:nvPr/>
+        </p:nvSpPr>
+        <p:spPr>
+          <a:xfrm>
+            <a:off x="7367213" y="2865845"/>
+            <a:ext cx="540000" cy="540000"/>
+          </a:xfrm>
+          <a:prstGeom prst="rect">
+            <a:avLst/>
+          </a:prstGeom>
+          <a:solidFill>
+            <a:srgbClr val="6AB5FF"/>
+          </a:solidFill>
+        </p:spPr>
+        <p:style>
+          <a:lnRef idx="2">
+            <a:schemeClr val="accent1">
+              <a:shade val="15000"/>
+            </a:schemeClr>
+          </a:lnRef>
+          <a:fillRef idx="1">
+            <a:schemeClr val="accent1"/>
+          </a:fillRef>
+          <a:effectRef idx="0">
+            <a:schemeClr val="accent1"/>
+          </a:effectRef>
+          <a:fontRef idx="minor">
+            <a:schemeClr val="lt1"/>
+          </a:fontRef>
+        </p:style>
+        <p:txBody>
+          <a:bodyPr rtlCol="0" anchor="ctr"/>
+          <a:lstStyle/>
+          <a:p>
+            <a:pPr algn="ctr"/>
+            <a:r>
+              <a:rPr lang="en-US" sz="1200" b="1" dirty="0"/>
+              <a:t>Value</a:t>
+            </a:r>
+          </a:p>
+        </p:txBody>
+      </p:sp>
+      <p:sp>
+        <p:nvSpPr>
+          <p:cNvPr id="85" name="Rectangle 84">
+            <a:extLst>
+              <a:ext uri="{FF2B5EF4-FFF2-40B4-BE49-F238E27FC236}">
+                <a16:creationId xmlns:a16="http://schemas.microsoft.com/office/drawing/2014/main" id="{538ED40E-C8CC-759A-0FF8-211CF22AC6AF}"/>
+              </a:ext>
+            </a:extLst>
+          </p:cNvPr>
+          <p:cNvSpPr/>
+          <p:nvPr/>
+        </p:nvSpPr>
+        <p:spPr>
+          <a:xfrm>
+            <a:off x="6827213" y="2865845"/>
+            <a:ext cx="540000" cy="540000"/>
+          </a:xfrm>
+          <a:prstGeom prst="rect">
+            <a:avLst/>
+          </a:prstGeom>
+          <a:solidFill>
+            <a:schemeClr val="accent5">
+              <a:lumMod val="50000"/>
+            </a:schemeClr>
+          </a:solidFill>
+        </p:spPr>
+        <p:style>
+          <a:lnRef idx="2">
+            <a:schemeClr val="accent1">
+              <a:shade val="15000"/>
+            </a:schemeClr>
+          </a:lnRef>
+          <a:fillRef idx="1">
+            <a:schemeClr val="accent1"/>
+          </a:fillRef>
+          <a:effectRef idx="0">
+            <a:schemeClr val="accent1"/>
+          </a:effectRef>
+          <a:fontRef idx="minor">
+            <a:schemeClr val="lt1"/>
+          </a:fontRef>
+        </p:style>
+        <p:txBody>
+          <a:bodyPr rtlCol="0" anchor="ctr"/>
+          <a:lstStyle/>
+          <a:p>
+            <a:pPr algn="ctr"/>
+            <a:r>
+              <a:rPr lang="en-US" sz="900" b="1" dirty="0"/>
+              <a:t>Left Pointer</a:t>
+            </a:r>
+          </a:p>
+        </p:txBody>
+      </p:sp>
+      <p:sp>
+        <p:nvSpPr>
+          <p:cNvPr id="86" name="Rectangle 85">
+            <a:extLst>
+              <a:ext uri="{FF2B5EF4-FFF2-40B4-BE49-F238E27FC236}">
+                <a16:creationId xmlns:a16="http://schemas.microsoft.com/office/drawing/2014/main" id="{69813463-08CE-395C-AFF8-7294B566D184}"/>
+              </a:ext>
+            </a:extLst>
+          </p:cNvPr>
+          <p:cNvSpPr/>
+          <p:nvPr/>
+        </p:nvSpPr>
+        <p:spPr>
+          <a:xfrm>
+            <a:off x="7907213" y="2865845"/>
+            <a:ext cx="540000" cy="540000"/>
+          </a:xfrm>
+          <a:prstGeom prst="rect">
+            <a:avLst/>
+          </a:prstGeom>
+          <a:solidFill>
+            <a:schemeClr val="accent5">
+              <a:lumMod val="50000"/>
+            </a:schemeClr>
+          </a:solidFill>
+        </p:spPr>
+        <p:style>
+          <a:lnRef idx="2">
+            <a:schemeClr val="accent1">
+              <a:shade val="15000"/>
+            </a:schemeClr>
+          </a:lnRef>
+          <a:fillRef idx="1">
+            <a:schemeClr val="accent1"/>
+          </a:fillRef>
+          <a:effectRef idx="0">
+            <a:schemeClr val="accent1"/>
+          </a:effectRef>
+          <a:fontRef idx="minor">
+            <a:schemeClr val="lt1"/>
+          </a:fontRef>
+        </p:style>
+        <p:txBody>
+          <a:bodyPr rtlCol="0" anchor="ctr"/>
+          <a:lstStyle/>
+          <a:p>
+            <a:pPr algn="ctr"/>
+            <a:r>
+              <a:rPr lang="en-US" sz="900" b="1" dirty="0"/>
+              <a:t>Right</a:t>
+            </a:r>
+          </a:p>
+          <a:p>
+            <a:pPr algn="ctr"/>
+            <a:r>
+              <a:rPr lang="en-US" sz="900" b="1" dirty="0"/>
+              <a:t>Pointer</a:t>
+            </a:r>
+          </a:p>
+        </p:txBody>
+      </p:sp>
+      <p:sp>
+        <p:nvSpPr>
+          <p:cNvPr id="87" name="Rectangle 86">
+            <a:extLst>
+              <a:ext uri="{FF2B5EF4-FFF2-40B4-BE49-F238E27FC236}">
+                <a16:creationId xmlns:a16="http://schemas.microsoft.com/office/drawing/2014/main" id="{F7026A71-666B-5DA4-B700-9FF7BE81204B}"/>
+              </a:ext>
+            </a:extLst>
+          </p:cNvPr>
+          <p:cNvSpPr/>
+          <p:nvPr/>
+        </p:nvSpPr>
+        <p:spPr>
+          <a:xfrm>
+            <a:off x="8438984" y="3825963"/>
+            <a:ext cx="540000" cy="540000"/>
+          </a:xfrm>
+          <a:prstGeom prst="rect">
+            <a:avLst/>
+          </a:prstGeom>
+          <a:solidFill>
+            <a:srgbClr val="6AB5FF"/>
+          </a:solidFill>
+        </p:spPr>
+        <p:style>
+          <a:lnRef idx="2">
+            <a:schemeClr val="accent1">
+              <a:shade val="15000"/>
+            </a:schemeClr>
+          </a:lnRef>
+          <a:fillRef idx="1">
+            <a:schemeClr val="accent1"/>
+          </a:fillRef>
+          <a:effectRef idx="0">
+            <a:schemeClr val="accent1"/>
+          </a:effectRef>
+          <a:fontRef idx="minor">
+            <a:schemeClr val="lt1"/>
+          </a:fontRef>
+        </p:style>
+        <p:txBody>
+          <a:bodyPr rtlCol="0" anchor="ctr"/>
+          <a:lstStyle/>
+          <a:p>
+            <a:pPr algn="ctr"/>
+            <a:r>
+              <a:rPr lang="en-US" sz="1200" b="1" dirty="0"/>
+              <a:t>Value</a:t>
+            </a:r>
+          </a:p>
+        </p:txBody>
+      </p:sp>
+      <p:sp>
+        <p:nvSpPr>
+          <p:cNvPr id="88" name="Rectangle 87">
+            <a:extLst>
+              <a:ext uri="{FF2B5EF4-FFF2-40B4-BE49-F238E27FC236}">
+                <a16:creationId xmlns:a16="http://schemas.microsoft.com/office/drawing/2014/main" id="{9FAC2B21-A147-E092-5358-1B29D9AD08F0}"/>
+              </a:ext>
+            </a:extLst>
+          </p:cNvPr>
+          <p:cNvSpPr/>
+          <p:nvPr/>
+        </p:nvSpPr>
+        <p:spPr>
+          <a:xfrm>
+            <a:off x="3384789" y="2865845"/>
+            <a:ext cx="540000" cy="540000"/>
+          </a:xfrm>
+          <a:prstGeom prst="rect">
+            <a:avLst/>
+          </a:prstGeom>
+          <a:solidFill>
+            <a:schemeClr val="accent5">
+              <a:lumMod val="50000"/>
+            </a:schemeClr>
+          </a:solidFill>
+        </p:spPr>
+        <p:style>
+          <a:lnRef idx="2">
+            <a:schemeClr val="accent1">
+              <a:shade val="15000"/>
+            </a:schemeClr>
+          </a:lnRef>
+          <a:fillRef idx="1">
+            <a:schemeClr val="accent1"/>
+          </a:fillRef>
+          <a:effectRef idx="0">
+            <a:schemeClr val="accent1"/>
+          </a:effectRef>
+          <a:fontRef idx="minor">
+            <a:schemeClr val="lt1"/>
+          </a:fontRef>
+        </p:style>
+        <p:txBody>
+          <a:bodyPr rtlCol="0" anchor="ctr"/>
+          <a:lstStyle/>
+          <a:p>
+            <a:pPr algn="ctr"/>
+            <a:r>
+              <a:rPr lang="en-US" sz="900" b="1" dirty="0"/>
+              <a:t>Left Pointer</a:t>
+            </a:r>
+          </a:p>
+        </p:txBody>
+      </p:sp>
+      <p:sp>
+        <p:nvSpPr>
+          <p:cNvPr id="89" name="Rectangle 88">
+            <a:extLst>
+              <a:ext uri="{FF2B5EF4-FFF2-40B4-BE49-F238E27FC236}">
+                <a16:creationId xmlns:a16="http://schemas.microsoft.com/office/drawing/2014/main" id="{0B359543-5504-DD22-0386-4F6D60B385C1}"/>
+              </a:ext>
+            </a:extLst>
+          </p:cNvPr>
+          <p:cNvSpPr/>
+          <p:nvPr/>
+        </p:nvSpPr>
+        <p:spPr>
+          <a:xfrm>
+            <a:off x="8978984" y="3825963"/>
+            <a:ext cx="540000" cy="540000"/>
+          </a:xfrm>
+          <a:prstGeom prst="rect">
+            <a:avLst/>
+          </a:prstGeom>
+          <a:solidFill>
+            <a:schemeClr val="accent5">
+              <a:lumMod val="50000"/>
+            </a:schemeClr>
+          </a:solidFill>
+        </p:spPr>
+        <p:style>
+          <a:lnRef idx="2">
+            <a:schemeClr val="accent1">
+              <a:shade val="15000"/>
+            </a:schemeClr>
+          </a:lnRef>
+          <a:fillRef idx="1">
+            <a:schemeClr val="accent1"/>
+          </a:fillRef>
+          <a:effectRef idx="0">
+            <a:schemeClr val="accent1"/>
+          </a:effectRef>
+          <a:fontRef idx="minor">
+            <a:schemeClr val="lt1"/>
+          </a:fontRef>
+        </p:style>
+        <p:txBody>
+          <a:bodyPr rtlCol="0" anchor="ctr"/>
+          <a:lstStyle/>
+          <a:p>
+            <a:pPr algn="ctr"/>
+            <a:r>
+              <a:rPr lang="en-US" sz="900" b="1" dirty="0"/>
+              <a:t>Right</a:t>
+            </a:r>
+          </a:p>
+          <a:p>
+            <a:pPr algn="ctr"/>
+            <a:r>
+              <a:rPr lang="en-US" sz="900" b="1" dirty="0"/>
+              <a:t>Pointer</a:t>
+            </a:r>
+          </a:p>
+        </p:txBody>
+      </p:sp>
+      <p:sp>
+        <p:nvSpPr>
+          <p:cNvPr id="90" name="Rectangle 89">
+            <a:extLst>
+              <a:ext uri="{FF2B5EF4-FFF2-40B4-BE49-F238E27FC236}">
+                <a16:creationId xmlns:a16="http://schemas.microsoft.com/office/drawing/2014/main" id="{6153B788-DFA0-137D-F656-04DDFE0194B1}"/>
+              </a:ext>
+            </a:extLst>
+          </p:cNvPr>
+          <p:cNvSpPr/>
+          <p:nvPr/>
+        </p:nvSpPr>
+        <p:spPr>
+          <a:xfrm>
+            <a:off x="2614791" y="3825963"/>
+            <a:ext cx="540000" cy="540000"/>
+          </a:xfrm>
+          <a:prstGeom prst="rect">
+            <a:avLst/>
+          </a:prstGeom>
+          <a:solidFill>
+            <a:srgbClr val="6AB5FF"/>
+          </a:solidFill>
+        </p:spPr>
+        <p:style>
+          <a:lnRef idx="2">
+            <a:schemeClr val="accent1">
+              <a:shade val="15000"/>
+            </a:schemeClr>
+          </a:lnRef>
+          <a:fillRef idx="1">
+            <a:schemeClr val="accent1"/>
+          </a:fillRef>
+          <a:effectRef idx="0">
+            <a:schemeClr val="accent1"/>
+          </a:effectRef>
+          <a:fontRef idx="minor">
+            <a:schemeClr val="lt1"/>
+          </a:fontRef>
+        </p:style>
+        <p:txBody>
+          <a:bodyPr rtlCol="0" anchor="ctr"/>
+          <a:lstStyle/>
+          <a:p>
+            <a:pPr algn="ctr"/>
+            <a:r>
+              <a:rPr lang="en-US" sz="1200" b="1" dirty="0"/>
+              <a:t>Value</a:t>
+            </a:r>
+          </a:p>
+        </p:txBody>
+      </p:sp>
+      <p:sp>
+        <p:nvSpPr>
+          <p:cNvPr id="91" name="Rectangle 90">
+            <a:extLst>
+              <a:ext uri="{FF2B5EF4-FFF2-40B4-BE49-F238E27FC236}">
+                <a16:creationId xmlns:a16="http://schemas.microsoft.com/office/drawing/2014/main" id="{006A7970-24C8-7343-33C8-BF0A80B86D05}"/>
+              </a:ext>
+            </a:extLst>
+          </p:cNvPr>
+          <p:cNvSpPr/>
+          <p:nvPr/>
+        </p:nvSpPr>
+        <p:spPr>
+          <a:xfrm>
+            <a:off x="2074791" y="3825963"/>
+            <a:ext cx="540000" cy="540000"/>
+          </a:xfrm>
+          <a:prstGeom prst="rect">
+            <a:avLst/>
+          </a:prstGeom>
+          <a:solidFill>
+            <a:schemeClr val="accent5">
+              <a:lumMod val="50000"/>
+            </a:schemeClr>
+          </a:solidFill>
+        </p:spPr>
+        <p:style>
+          <a:lnRef idx="2">
+            <a:schemeClr val="accent1">
+              <a:shade val="15000"/>
+            </a:schemeClr>
+          </a:lnRef>
+          <a:fillRef idx="1">
+            <a:schemeClr val="accent1"/>
+          </a:fillRef>
+          <a:effectRef idx="0">
+            <a:schemeClr val="accent1"/>
+          </a:effectRef>
+          <a:fontRef idx="minor">
+            <a:schemeClr val="lt1"/>
+          </a:fontRef>
+        </p:style>
+        <p:txBody>
+          <a:bodyPr rtlCol="0" anchor="ctr"/>
+          <a:lstStyle/>
+          <a:p>
+            <a:pPr algn="ctr"/>
+            <a:r>
+              <a:rPr lang="en-US" sz="900" b="1" dirty="0"/>
+              <a:t>Left Pointer</a:t>
+            </a:r>
+          </a:p>
+        </p:txBody>
+      </p:sp>
+      <p:sp>
+        <p:nvSpPr>
+          <p:cNvPr id="92" name="Rectangle 91">
+            <a:extLst>
+              <a:ext uri="{FF2B5EF4-FFF2-40B4-BE49-F238E27FC236}">
+                <a16:creationId xmlns:a16="http://schemas.microsoft.com/office/drawing/2014/main" id="{5BA15602-1E89-DCB8-B0B3-3AF10120C860}"/>
+              </a:ext>
+            </a:extLst>
+          </p:cNvPr>
+          <p:cNvSpPr/>
+          <p:nvPr/>
+        </p:nvSpPr>
+        <p:spPr>
+          <a:xfrm>
+            <a:off x="3154791" y="3825963"/>
+            <a:ext cx="540000" cy="540000"/>
+          </a:xfrm>
+          <a:prstGeom prst="rect">
+            <a:avLst/>
+          </a:prstGeom>
+          <a:solidFill>
+            <a:schemeClr val="accent5">
+              <a:lumMod val="50000"/>
+            </a:schemeClr>
+          </a:solidFill>
+        </p:spPr>
+        <p:style>
+          <a:lnRef idx="2">
+            <a:schemeClr val="accent1">
+              <a:shade val="15000"/>
+            </a:schemeClr>
+          </a:lnRef>
+          <a:fillRef idx="1">
+            <a:schemeClr val="accent1"/>
+          </a:fillRef>
+          <a:effectRef idx="0">
+            <a:schemeClr val="accent1"/>
+          </a:effectRef>
+          <a:fontRef idx="minor">
+            <a:schemeClr val="lt1"/>
+          </a:fontRef>
+        </p:style>
+        <p:txBody>
+          <a:bodyPr rtlCol="0" anchor="ctr"/>
+          <a:lstStyle/>
+          <a:p>
+            <a:pPr algn="ctr"/>
+            <a:r>
+              <a:rPr lang="en-US" sz="900" b="1" dirty="0"/>
+              <a:t>Right</a:t>
+            </a:r>
+          </a:p>
+          <a:p>
+            <a:pPr algn="ctr"/>
+            <a:r>
+              <a:rPr lang="en-US" sz="900" b="1" dirty="0"/>
+              <a:t>Pointer</a:t>
+            </a:r>
+          </a:p>
+        </p:txBody>
+      </p:sp>
+      <p:sp>
+        <p:nvSpPr>
+          <p:cNvPr id="2" name="TextBox 1">
+            <a:extLst>
+              <a:ext uri="{FF2B5EF4-FFF2-40B4-BE49-F238E27FC236}">
+                <a16:creationId xmlns:a16="http://schemas.microsoft.com/office/drawing/2014/main" id="{62757CFA-06BE-5E89-FB7A-C7A11E2FF38A}"/>
               </a:ext>
             </a:extLst>
           </p:cNvPr>
@@ -7573,16 +8370,294 @@
           </a:p>
         </p:txBody>
       </p:sp>
+      <p:sp>
+        <p:nvSpPr>
+          <p:cNvPr id="11" name="Rectangle 10">
+            <a:extLst>
+              <a:ext uri="{FF2B5EF4-FFF2-40B4-BE49-F238E27FC236}">
+                <a16:creationId xmlns:a16="http://schemas.microsoft.com/office/drawing/2014/main" id="{6B726CA4-E7AE-8BA0-FA50-67C26B7F2BC5}"/>
+              </a:ext>
+            </a:extLst>
+          </p:cNvPr>
+          <p:cNvSpPr/>
+          <p:nvPr/>
+        </p:nvSpPr>
+        <p:spPr>
+          <a:xfrm>
+            <a:off x="7907213" y="3825963"/>
+            <a:ext cx="540000" cy="540000"/>
+          </a:xfrm>
+          <a:prstGeom prst="rect">
+            <a:avLst/>
+          </a:prstGeom>
+          <a:solidFill>
+            <a:schemeClr val="accent5">
+              <a:lumMod val="50000"/>
+            </a:schemeClr>
+          </a:solidFill>
+        </p:spPr>
+        <p:style>
+          <a:lnRef idx="2">
+            <a:schemeClr val="accent1">
+              <a:shade val="15000"/>
+            </a:schemeClr>
+          </a:lnRef>
+          <a:fillRef idx="1">
+            <a:schemeClr val="accent1"/>
+          </a:fillRef>
+          <a:effectRef idx="0">
+            <a:schemeClr val="accent1"/>
+          </a:effectRef>
+          <a:fontRef idx="minor">
+            <a:schemeClr val="lt1"/>
+          </a:fontRef>
+        </p:style>
+        <p:txBody>
+          <a:bodyPr rtlCol="0" anchor="ctr"/>
+          <a:lstStyle/>
+          <a:p>
+            <a:pPr algn="ctr"/>
+            <a:r>
+              <a:rPr lang="en-US" sz="900" b="1" dirty="0"/>
+              <a:t>Left Pointer</a:t>
+            </a:r>
+          </a:p>
+        </p:txBody>
+      </p:sp>
+      <p:sp>
+        <p:nvSpPr>
+          <p:cNvPr id="12" name="Rectangle 11">
+            <a:extLst>
+              <a:ext uri="{FF2B5EF4-FFF2-40B4-BE49-F238E27FC236}">
+                <a16:creationId xmlns:a16="http://schemas.microsoft.com/office/drawing/2014/main" id="{EEAF8C38-CF79-6340-E4CB-0B618932233E}"/>
+              </a:ext>
+            </a:extLst>
+          </p:cNvPr>
+          <p:cNvSpPr/>
+          <p:nvPr/>
+        </p:nvSpPr>
+        <p:spPr>
+          <a:xfrm>
+            <a:off x="5006888" y="3824961"/>
+            <a:ext cx="540000" cy="540000"/>
+          </a:xfrm>
+          <a:prstGeom prst="rect">
+            <a:avLst/>
+          </a:prstGeom>
+          <a:solidFill>
+            <a:srgbClr val="6AB5FF"/>
+          </a:solidFill>
+        </p:spPr>
+        <p:style>
+          <a:lnRef idx="2">
+            <a:schemeClr val="accent1">
+              <a:shade val="15000"/>
+            </a:schemeClr>
+          </a:lnRef>
+          <a:fillRef idx="1">
+            <a:schemeClr val="accent1"/>
+          </a:fillRef>
+          <a:effectRef idx="0">
+            <a:schemeClr val="accent1"/>
+          </a:effectRef>
+          <a:fontRef idx="minor">
+            <a:schemeClr val="lt1"/>
+          </a:fontRef>
+        </p:style>
+        <p:txBody>
+          <a:bodyPr rtlCol="0" anchor="ctr"/>
+          <a:lstStyle/>
+          <a:p>
+            <a:pPr algn="ctr"/>
+            <a:r>
+              <a:rPr lang="en-US" sz="1200" b="1" dirty="0"/>
+              <a:t>Value</a:t>
+            </a:r>
+          </a:p>
+        </p:txBody>
+      </p:sp>
+      <p:sp>
+        <p:nvSpPr>
+          <p:cNvPr id="13" name="Rectangle 12">
+            <a:extLst>
+              <a:ext uri="{FF2B5EF4-FFF2-40B4-BE49-F238E27FC236}">
+                <a16:creationId xmlns:a16="http://schemas.microsoft.com/office/drawing/2014/main" id="{F93E0D11-54E8-C4AD-4CF5-3BB2D1A5914C}"/>
+              </a:ext>
+            </a:extLst>
+          </p:cNvPr>
+          <p:cNvSpPr/>
+          <p:nvPr/>
+        </p:nvSpPr>
+        <p:spPr>
+          <a:xfrm>
+            <a:off x="5546888" y="3824961"/>
+            <a:ext cx="540000" cy="540000"/>
+          </a:xfrm>
+          <a:prstGeom prst="rect">
+            <a:avLst/>
+          </a:prstGeom>
+          <a:solidFill>
+            <a:schemeClr val="accent5">
+              <a:lumMod val="50000"/>
+            </a:schemeClr>
+          </a:solidFill>
+        </p:spPr>
+        <p:style>
+          <a:lnRef idx="2">
+            <a:schemeClr val="accent1">
+              <a:shade val="15000"/>
+            </a:schemeClr>
+          </a:lnRef>
+          <a:fillRef idx="1">
+            <a:schemeClr val="accent1"/>
+          </a:fillRef>
+          <a:effectRef idx="0">
+            <a:schemeClr val="accent1"/>
+          </a:effectRef>
+          <a:fontRef idx="minor">
+            <a:schemeClr val="lt1"/>
+          </a:fontRef>
+        </p:style>
+        <p:txBody>
+          <a:bodyPr rtlCol="0" anchor="ctr"/>
+          <a:lstStyle/>
+          <a:p>
+            <a:pPr algn="ctr"/>
+            <a:r>
+              <a:rPr lang="en-US" sz="900" b="1" dirty="0"/>
+              <a:t>Right</a:t>
+            </a:r>
+          </a:p>
+          <a:p>
+            <a:pPr algn="ctr"/>
+            <a:r>
+              <a:rPr lang="en-US" sz="900" b="1" dirty="0"/>
+              <a:t>Pointer</a:t>
+            </a:r>
+          </a:p>
+        </p:txBody>
+      </p:sp>
+      <p:sp>
+        <p:nvSpPr>
+          <p:cNvPr id="14" name="Rectangle 13">
+            <a:extLst>
+              <a:ext uri="{FF2B5EF4-FFF2-40B4-BE49-F238E27FC236}">
+                <a16:creationId xmlns:a16="http://schemas.microsoft.com/office/drawing/2014/main" id="{7B72D703-F8E7-007F-4212-07833D9BA806}"/>
+              </a:ext>
+            </a:extLst>
+          </p:cNvPr>
+          <p:cNvSpPr/>
+          <p:nvPr/>
+        </p:nvSpPr>
+        <p:spPr>
+          <a:xfrm>
+            <a:off x="4475117" y="3824961"/>
+            <a:ext cx="540000" cy="540000"/>
+          </a:xfrm>
+          <a:prstGeom prst="rect">
+            <a:avLst/>
+          </a:prstGeom>
+          <a:solidFill>
+            <a:schemeClr val="accent5">
+              <a:lumMod val="50000"/>
+            </a:schemeClr>
+          </a:solidFill>
+        </p:spPr>
+        <p:style>
+          <a:lnRef idx="2">
+            <a:schemeClr val="accent1">
+              <a:shade val="15000"/>
+            </a:schemeClr>
+          </a:lnRef>
+          <a:fillRef idx="1">
+            <a:schemeClr val="accent1"/>
+          </a:fillRef>
+          <a:effectRef idx="0">
+            <a:schemeClr val="accent1"/>
+          </a:effectRef>
+          <a:fontRef idx="minor">
+            <a:schemeClr val="lt1"/>
+          </a:fontRef>
+        </p:style>
+        <p:txBody>
+          <a:bodyPr rtlCol="0" anchor="ctr"/>
+          <a:lstStyle/>
+          <a:p>
+            <a:pPr algn="ctr"/>
+            <a:r>
+              <a:rPr lang="en-US" sz="900" b="1" dirty="0"/>
+              <a:t>Left Pointer</a:t>
+            </a:r>
+          </a:p>
+        </p:txBody>
+      </p:sp>
+      <p:cxnSp>
+        <p:nvCxnSpPr>
+          <p:cNvPr id="15" name="Straight Connector 14">
+            <a:extLst>
+              <a:ext uri="{FF2B5EF4-FFF2-40B4-BE49-F238E27FC236}">
+                <a16:creationId xmlns:a16="http://schemas.microsoft.com/office/drawing/2014/main" id="{2A5F6DC8-128C-A596-4819-37B438B4DF5F}"/>
+              </a:ext>
+            </a:extLst>
+          </p:cNvPr>
+          <p:cNvCxnSpPr>
+            <a:cxnSpLocks/>
+            <a:stCxn id="12" idx="0"/>
+            <a:endCxn id="83" idx="2"/>
+          </p:cNvCxnSpPr>
+          <p:nvPr/>
+        </p:nvCxnSpPr>
+        <p:spPr>
+          <a:xfrm flipH="1" flipV="1">
+            <a:off x="4746001" y="3405845"/>
+            <a:ext cx="530887" cy="419116"/>
+          </a:xfrm>
+          <a:prstGeom prst="line">
+            <a:avLst/>
+          </a:prstGeom>
+          <a:ln w="38100">
+            <a:solidFill>
+              <a:srgbClr val="AAAAAA"/>
+            </a:solidFill>
+          </a:ln>
+        </p:spPr>
+        <p:style>
+          <a:lnRef idx="1">
+            <a:schemeClr val="accent1"/>
+          </a:lnRef>
+          <a:fillRef idx="0">
+            <a:schemeClr val="accent1"/>
+          </a:fillRef>
+          <a:effectRef idx="0">
+            <a:schemeClr val="accent1"/>
+          </a:effectRef>
+          <a:fontRef idx="minor">
+            <a:schemeClr val="tx1"/>
+          </a:fontRef>
+        </p:style>
+      </p:cxnSp>
     </p:spTree>
     <p:extLst>
       <p:ext uri="{BB962C8B-B14F-4D97-AF65-F5344CB8AC3E}">
-        <p14:creationId xmlns:p14="http://schemas.microsoft.com/office/powerpoint/2010/main" val="3583032911"/>
+        <p14:creationId xmlns:p14="http://schemas.microsoft.com/office/powerpoint/2010/main" val="3529036991"/>
       </p:ext>
     </p:extLst>
   </p:cSld>
   <p:clrMapOvr>
     <a:masterClrMapping/>
   </p:clrMapOvr>
+  <mc:AlternateContent xmlns:mc="http://schemas.openxmlformats.org/markup-compatibility/2006" xmlns:p159="http://schemas.microsoft.com/office/powerpoint/2015/09/main">
+    <mc:Choice Requires="p159">
+      <p:transition xmlns:p14="http://schemas.microsoft.com/office/powerpoint/2010/main" spd="slow" p14:dur="2000">
+        <p159:morph option="byObject"/>
+      </p:transition>
+    </mc:Choice>
+    <mc:Fallback xmlns="">
+      <p:transition spd="slow">
+        <p:fade/>
+      </p:transition>
+    </mc:Fallback>
+  </mc:AlternateContent>
 </p:sld>
 </file>
 
@@ -25509,7 +26584,13 @@
     </p:bg>
     <p:spTree>
       <p:nvGrpSpPr>
-        <p:cNvPr id="1" name=""/>
+        <p:cNvPr id="1" name="">
+          <a:extLst>
+            <a:ext uri="{FF2B5EF4-FFF2-40B4-BE49-F238E27FC236}">
+              <a16:creationId xmlns:a16="http://schemas.microsoft.com/office/drawing/2014/main" id="{205744AF-DA71-F5F9-36A7-5CDC1EB6E59B}"/>
+            </a:ext>
+          </a:extLst>
+        </p:cNvPr>
         <p:cNvGrpSpPr/>
         <p:nvPr/>
       </p:nvGrpSpPr>
@@ -25526,7 +26607,7 @@
           <p:cNvPr id="5" name="Title 1">
             <a:extLst>
               <a:ext uri="{FF2B5EF4-FFF2-40B4-BE49-F238E27FC236}">
-                <a16:creationId xmlns:a16="http://schemas.microsoft.com/office/drawing/2014/main" id="{D359A545-5E0C-E6E5-274C-D470E99B10C7}"/>
+                <a16:creationId xmlns:a16="http://schemas.microsoft.com/office/drawing/2014/main" id="{71AEDA62-094B-FBBE-E395-382117D81280}"/>
               </a:ext>
             </a:extLst>
           </p:cNvPr>
@@ -25550,10 +26631,11 @@
           <a:lstStyle/>
           <a:p>
             <a:r>
-              <a:rPr lang="en-US" b="1" dirty="0" err="1">
+              <a:rPr lang="en-US" sz="6000" b="1" i="0" dirty="0" err="1">
                 <a:solidFill>
                   <a:srgbClr val="00B050"/>
                 </a:solidFill>
+                <a:effectLst/>
               </a:rPr>
               <a:t>TreeNode</a:t>
             </a:r>
@@ -25570,7 +26652,7 @@
           <p:cNvPr id="8" name="TextBox 7">
             <a:extLst>
               <a:ext uri="{FF2B5EF4-FFF2-40B4-BE49-F238E27FC236}">
-                <a16:creationId xmlns:a16="http://schemas.microsoft.com/office/drawing/2014/main" id="{4E1121B2-8C34-C723-AA30-2A804B79DD2B}"/>
+                <a16:creationId xmlns:a16="http://schemas.microsoft.com/office/drawing/2014/main" id="{D3F4B476-DFE7-1FC7-8408-B8101B2765C8}"/>
               </a:ext>
             </a:extLst>
           </p:cNvPr>
@@ -25600,9 +26682,65 @@
                   <a:schemeClr val="bg1"/>
                 </a:solidFill>
               </a:rPr>
-              <a:t>A node in a tree has a value, and a left and right pointer</a:t>
-            </a:r>
-            <a:endParaRPr lang="en-US" sz="2500" dirty="0">
+              <a:t>Each node in a </a:t>
+            </a:r>
+            <a:r>
+              <a:rPr lang="en-PH" sz="2500" dirty="0">
+                <a:solidFill>
+                  <a:srgbClr val="00B0F0"/>
+                </a:solidFill>
+              </a:rPr>
+              <a:t>binary tree </a:t>
+            </a:r>
+            <a:r>
+              <a:rPr lang="en-PH" sz="2500" dirty="0">
+                <a:solidFill>
+                  <a:schemeClr val="bg1"/>
+                </a:solidFill>
+              </a:rPr>
+              <a:t>has a </a:t>
+            </a:r>
+            <a:r>
+              <a:rPr lang="en-PH" sz="2500" b="1" dirty="0">
+                <a:solidFill>
+                  <a:schemeClr val="bg1"/>
+                </a:solidFill>
+              </a:rPr>
+              <a:t>value</a:t>
+            </a:r>
+            <a:r>
+              <a:rPr lang="en-PH" sz="2500" dirty="0">
+                <a:solidFill>
+                  <a:schemeClr val="bg1"/>
+                </a:solidFill>
+              </a:rPr>
+              <a:t> and a </a:t>
+            </a:r>
+            <a:r>
+              <a:rPr lang="en-PH" sz="2500" b="1" dirty="0">
+                <a:solidFill>
+                  <a:schemeClr val="bg1"/>
+                </a:solidFill>
+              </a:rPr>
+              <a:t>left</a:t>
+            </a:r>
+            <a:r>
+              <a:rPr lang="en-PH" sz="2500" dirty="0">
+                <a:solidFill>
+                  <a:schemeClr val="bg1"/>
+                </a:solidFill>
+              </a:rPr>
+              <a:t> and </a:t>
+            </a:r>
+            <a:r>
+              <a:rPr lang="en-PH" sz="2500" b="1" dirty="0">
+                <a:solidFill>
+                  <a:schemeClr val="bg1"/>
+                </a:solidFill>
+              </a:rPr>
+              <a:t>right pointer</a:t>
+            </a:r>
+            <a:endParaRPr lang="en-US" sz="2500" b="1" dirty="0">
               <a:solidFill>
                 <a:schemeClr val="bg1"/>
               </a:solidFill>
@@ -25615,7 +26753,7 @@
           <p:cNvPr id="6" name="Rectangle 5">
             <a:extLst>
               <a:ext uri="{FF2B5EF4-FFF2-40B4-BE49-F238E27FC236}">
-                <a16:creationId xmlns:a16="http://schemas.microsoft.com/office/drawing/2014/main" id="{C448833F-CA0E-8DDE-F7CE-0789C8A2C001}"/>
+                <a16:creationId xmlns:a16="http://schemas.microsoft.com/office/drawing/2014/main" id="{6F8B0BD4-8758-2596-64E8-953AD64BFB56}"/>
               </a:ext>
             </a:extLst>
           </p:cNvPr>
@@ -25624,8 +26762,8 @@
         </p:nvSpPr>
         <p:spPr>
           <a:xfrm>
-            <a:off x="5614586" y="1636729"/>
-            <a:ext cx="540000" cy="540000"/>
+            <a:off x="5371142" y="2442714"/>
+            <a:ext cx="1800000" cy="1800000"/>
           </a:xfrm>
           <a:prstGeom prst="rect">
             <a:avLst/>
@@ -25656,7 +26794,7 @@
           <a:p>
             <a:pPr algn="ctr"/>
             <a:r>
-              <a:rPr lang="en-US" sz="1200" b="1" dirty="0"/>
+              <a:rPr lang="en-US" sz="4000" b="1" dirty="0"/>
               <a:t>Value</a:t>
             </a:r>
           </a:p>
@@ -25667,7 +26805,7 @@
           <p:cNvPr id="3" name="Rectangle 2">
             <a:extLst>
               <a:ext uri="{FF2B5EF4-FFF2-40B4-BE49-F238E27FC236}">
-                <a16:creationId xmlns:a16="http://schemas.microsoft.com/office/drawing/2014/main" id="{7145F0CD-9B66-12B7-3CAB-E65F729BD19C}"/>
+                <a16:creationId xmlns:a16="http://schemas.microsoft.com/office/drawing/2014/main" id="{B7FF0E3B-C7C8-30DC-7740-8DCD8C7847B3}"/>
               </a:ext>
             </a:extLst>
           </p:cNvPr>
@@ -25676,8 +26814,8 @@
         </p:nvSpPr>
         <p:spPr>
           <a:xfrm>
-            <a:off x="5074586" y="1636729"/>
-            <a:ext cx="540000" cy="540000"/>
+            <a:off x="3571142" y="2442714"/>
+            <a:ext cx="1800000" cy="1800000"/>
           </a:xfrm>
           <a:prstGeom prst="rect">
             <a:avLst/>
@@ -25710,7 +26848,7 @@
           <a:p>
             <a:pPr algn="ctr"/>
             <a:r>
-              <a:rPr lang="en-US" sz="900" b="1" dirty="0"/>
+              <a:rPr lang="en-US" sz="4000" b="1" dirty="0"/>
               <a:t>Left Pointer</a:t>
             </a:r>
           </a:p>
@@ -25721,7 +26859,7 @@
           <p:cNvPr id="4" name="Rectangle 3">
             <a:extLst>
               <a:ext uri="{FF2B5EF4-FFF2-40B4-BE49-F238E27FC236}">
-                <a16:creationId xmlns:a16="http://schemas.microsoft.com/office/drawing/2014/main" id="{23E60267-87A9-5C01-0B32-657549E1BE34}"/>
+                <a16:creationId xmlns:a16="http://schemas.microsoft.com/office/drawing/2014/main" id="{783CBFDE-2FD0-BF4F-44D6-267789B39644}"/>
               </a:ext>
             </a:extLst>
           </p:cNvPr>
@@ -25730,8 +26868,8 @@
         </p:nvSpPr>
         <p:spPr>
           <a:xfrm>
-            <a:off x="6132772" y="1636729"/>
-            <a:ext cx="540000" cy="540000"/>
+            <a:off x="7171142" y="2442714"/>
+            <a:ext cx="1800000" cy="1800000"/>
           </a:xfrm>
           <a:prstGeom prst="rect">
             <a:avLst/>
@@ -25764,14 +26902,14 @@
           <a:p>
             <a:pPr algn="ctr"/>
             <a:r>
-              <a:rPr lang="en-US" sz="900" b="1" dirty="0"/>
+              <a:rPr lang="en-US" sz="4000" b="1" dirty="0"/>
               <a:t>Right</a:t>
             </a:r>
           </a:p>
           <a:p>
             <a:pPr algn="ctr"/>
             <a:r>
-              <a:rPr lang="en-US" sz="900" b="1" dirty="0"/>
+              <a:rPr lang="en-US" sz="4000" b="1" dirty="0"/>
               <a:t>Pointer</a:t>
             </a:r>
           </a:p>
@@ -25779,10 +26917,10 @@
       </p:sp>
       <p:sp>
         <p:nvSpPr>
-          <p:cNvPr id="95" name="TextBox 94">
-            <a:extLst>
-              <a:ext uri="{FF2B5EF4-FFF2-40B4-BE49-F238E27FC236}">
-                <a16:creationId xmlns:a16="http://schemas.microsoft.com/office/drawing/2014/main" id="{DC577992-DB1B-F2C7-097E-925D799D9F55}"/>
+          <p:cNvPr id="7" name="TextBox 6">
+            <a:extLst>
+              <a:ext uri="{FF2B5EF4-FFF2-40B4-BE49-F238E27FC236}">
+                <a16:creationId xmlns:a16="http://schemas.microsoft.com/office/drawing/2014/main" id="{DA88E708-C839-A39B-1DD4-CC6E910A2613}"/>
               </a:ext>
             </a:extLst>
           </p:cNvPr>
@@ -26073,25 +27211,13 @@
     </p:spTree>
     <p:extLst>
       <p:ext uri="{BB962C8B-B14F-4D97-AF65-F5344CB8AC3E}">
-        <p14:creationId xmlns:p14="http://schemas.microsoft.com/office/powerpoint/2010/main" val="2301016541"/>
+        <p14:creationId xmlns:p14="http://schemas.microsoft.com/office/powerpoint/2010/main" val="3583032911"/>
       </p:ext>
     </p:extLst>
   </p:cSld>
   <p:clrMapOvr>
     <a:masterClrMapping/>
   </p:clrMapOvr>
-  <mc:AlternateContent xmlns:mc="http://schemas.openxmlformats.org/markup-compatibility/2006" xmlns:p159="http://schemas.microsoft.com/office/powerpoint/2015/09/main">
-    <mc:Choice Requires="p159">
-      <p:transition xmlns:p14="http://schemas.microsoft.com/office/powerpoint/2010/main" spd="slow" p14:dur="2000">
-        <p159:morph option="byObject"/>
-      </p:transition>
-    </mc:Choice>
-    <mc:Fallback xmlns="">
-      <p:transition spd="slow">
-        <p:fade/>
-      </p:transition>
-    </mc:Fallback>
-  </mc:AlternateContent>
 </p:sld>
 </file>
 
@@ -40620,13 +41746,7 @@
     </p:bg>
     <p:spTree>
       <p:nvGrpSpPr>
-        <p:cNvPr id="1" name="">
-          <a:extLst>
-            <a:ext uri="{FF2B5EF4-FFF2-40B4-BE49-F238E27FC236}">
-              <a16:creationId xmlns:a16="http://schemas.microsoft.com/office/drawing/2014/main" id="{2774B763-0D9B-5461-69C0-39C704F058B8}"/>
-            </a:ext>
-          </a:extLst>
-        </p:cNvPr>
+        <p:cNvPr id="1" name=""/>
         <p:cNvGrpSpPr/>
         <p:nvPr/>
       </p:nvGrpSpPr>
@@ -40643,7 +41763,7 @@
           <p:cNvPr id="5" name="Title 1">
             <a:extLst>
               <a:ext uri="{FF2B5EF4-FFF2-40B4-BE49-F238E27FC236}">
-                <a16:creationId xmlns:a16="http://schemas.microsoft.com/office/drawing/2014/main" id="{36451F85-7493-B35F-FDBC-644A3480A778}"/>
+                <a16:creationId xmlns:a16="http://schemas.microsoft.com/office/drawing/2014/main" id="{D359A545-5E0C-E6E5-274C-D470E99B10C7}"/>
               </a:ext>
             </a:extLst>
           </p:cNvPr>
@@ -40687,7 +41807,7 @@
           <p:cNvPr id="8" name="TextBox 7">
             <a:extLst>
               <a:ext uri="{FF2B5EF4-FFF2-40B4-BE49-F238E27FC236}">
-                <a16:creationId xmlns:a16="http://schemas.microsoft.com/office/drawing/2014/main" id="{10888BF8-92F1-F7F7-8B9E-1754C6A0FA5B}"/>
+                <a16:creationId xmlns:a16="http://schemas.microsoft.com/office/drawing/2014/main" id="{4E1121B2-8C34-C723-AA30-2A804B79DD2B}"/>
               </a:ext>
             </a:extLst>
           </p:cNvPr>
@@ -40717,15 +41837,7 @@
                   <a:schemeClr val="bg1"/>
                 </a:solidFill>
               </a:rPr>
-              <a:t>An implementation of a binary tree is </a:t>
-            </a:r>
-            <a:r>
-              <a:rPr lang="en-PH" sz="2500">
-                <a:solidFill>
-                  <a:schemeClr val="bg1"/>
-                </a:solidFill>
-              </a:rPr>
-              <a:t>a non-linear linked list</a:t>
+              <a:t>A node in a tree has a value, and a left and right pointer</a:t>
             </a:r>
             <a:endParaRPr lang="en-US" sz="2500" dirty="0">
               <a:solidFill>
@@ -40740,7 +41852,7 @@
           <p:cNvPr id="6" name="Rectangle 5">
             <a:extLst>
               <a:ext uri="{FF2B5EF4-FFF2-40B4-BE49-F238E27FC236}">
-                <a16:creationId xmlns:a16="http://schemas.microsoft.com/office/drawing/2014/main" id="{FFC5B58E-E56E-D5B2-F979-AEDABFE4EA4A}"/>
+                <a16:creationId xmlns:a16="http://schemas.microsoft.com/office/drawing/2014/main" id="{C448833F-CA0E-8DDE-F7CE-0789C8A2C001}"/>
               </a:ext>
             </a:extLst>
           </p:cNvPr>
@@ -40792,7 +41904,7 @@
           <p:cNvPr id="3" name="Rectangle 2">
             <a:extLst>
               <a:ext uri="{FF2B5EF4-FFF2-40B4-BE49-F238E27FC236}">
-                <a16:creationId xmlns:a16="http://schemas.microsoft.com/office/drawing/2014/main" id="{FFCA009C-85B1-F720-27D3-4180E15A9C7B}"/>
+                <a16:creationId xmlns:a16="http://schemas.microsoft.com/office/drawing/2014/main" id="{7145F0CD-9B66-12B7-3CAB-E65F729BD19C}"/>
               </a:ext>
             </a:extLst>
           </p:cNvPr>
@@ -40846,7 +41958,7 @@
           <p:cNvPr id="4" name="Rectangle 3">
             <a:extLst>
               <a:ext uri="{FF2B5EF4-FFF2-40B4-BE49-F238E27FC236}">
-                <a16:creationId xmlns:a16="http://schemas.microsoft.com/office/drawing/2014/main" id="{26F9F5DA-E232-EB49-B2CB-6A93CED76164}"/>
+                <a16:creationId xmlns:a16="http://schemas.microsoft.com/office/drawing/2014/main" id="{23E60267-87A9-5C01-0B32-657549E1BE34}"/>
               </a:ext>
             </a:extLst>
           </p:cNvPr>
@@ -40902,858 +42014,12 @@
           </a:p>
         </p:txBody>
       </p:sp>
-      <p:cxnSp>
-        <p:nvCxnSpPr>
-          <p:cNvPr id="77" name="Straight Connector 76">
-            <a:extLst>
-              <a:ext uri="{FF2B5EF4-FFF2-40B4-BE49-F238E27FC236}">
-                <a16:creationId xmlns:a16="http://schemas.microsoft.com/office/drawing/2014/main" id="{78E187FB-5008-35C6-669F-25AAD7549486}"/>
-              </a:ext>
-            </a:extLst>
-          </p:cNvPr>
-          <p:cNvCxnSpPr>
-            <a:cxnSpLocks/>
-            <a:stCxn id="81" idx="0"/>
-          </p:cNvCxnSpPr>
-          <p:nvPr/>
-        </p:nvCxnSpPr>
-        <p:spPr>
-          <a:xfrm flipV="1">
-            <a:off x="4206001" y="2176729"/>
-            <a:ext cx="1138585" cy="689116"/>
-          </a:xfrm>
-          <a:prstGeom prst="line">
-            <a:avLst/>
-          </a:prstGeom>
-          <a:ln w="38100">
-            <a:solidFill>
-              <a:srgbClr val="AAAAAA"/>
-            </a:solidFill>
-          </a:ln>
-        </p:spPr>
-        <p:style>
-          <a:lnRef idx="1">
-            <a:schemeClr val="accent1"/>
-          </a:lnRef>
-          <a:fillRef idx="0">
-            <a:schemeClr val="accent1"/>
-          </a:fillRef>
-          <a:effectRef idx="0">
-            <a:schemeClr val="accent1"/>
-          </a:effectRef>
-          <a:fontRef idx="minor">
-            <a:schemeClr val="tx1"/>
-          </a:fontRef>
-        </p:style>
-      </p:cxnSp>
-      <p:cxnSp>
-        <p:nvCxnSpPr>
-          <p:cNvPr id="78" name="Straight Connector 77">
-            <a:extLst>
-              <a:ext uri="{FF2B5EF4-FFF2-40B4-BE49-F238E27FC236}">
-                <a16:creationId xmlns:a16="http://schemas.microsoft.com/office/drawing/2014/main" id="{119ADAB8-B729-A132-1024-46A974AED851}"/>
-              </a:ext>
-            </a:extLst>
-          </p:cNvPr>
-          <p:cNvCxnSpPr>
-            <a:cxnSpLocks/>
-            <a:stCxn id="84" idx="0"/>
-          </p:cNvCxnSpPr>
-          <p:nvPr/>
-        </p:nvCxnSpPr>
-        <p:spPr>
-          <a:xfrm flipH="1" flipV="1">
-            <a:off x="6402772" y="2176729"/>
-            <a:ext cx="1234441" cy="689116"/>
-          </a:xfrm>
-          <a:prstGeom prst="line">
-            <a:avLst/>
-          </a:prstGeom>
-          <a:ln w="38100">
-            <a:solidFill>
-              <a:srgbClr val="AAAAAA"/>
-            </a:solidFill>
-          </a:ln>
-        </p:spPr>
-        <p:style>
-          <a:lnRef idx="1">
-            <a:schemeClr val="accent1"/>
-          </a:lnRef>
-          <a:fillRef idx="0">
-            <a:schemeClr val="accent1"/>
-          </a:fillRef>
-          <a:effectRef idx="0">
-            <a:schemeClr val="accent1"/>
-          </a:effectRef>
-          <a:fontRef idx="minor">
-            <a:schemeClr val="tx1"/>
-          </a:fontRef>
-        </p:style>
-      </p:cxnSp>
-      <p:cxnSp>
-        <p:nvCxnSpPr>
-          <p:cNvPr id="79" name="Straight Connector 78">
-            <a:extLst>
-              <a:ext uri="{FF2B5EF4-FFF2-40B4-BE49-F238E27FC236}">
-                <a16:creationId xmlns:a16="http://schemas.microsoft.com/office/drawing/2014/main" id="{01689E5D-2681-B5D6-7D3D-681242ED8C10}"/>
-              </a:ext>
-            </a:extLst>
-          </p:cNvPr>
-          <p:cNvCxnSpPr>
-            <a:cxnSpLocks/>
-            <a:stCxn id="90" idx="0"/>
-            <a:endCxn id="88" idx="2"/>
-          </p:cNvCxnSpPr>
-          <p:nvPr/>
-        </p:nvCxnSpPr>
-        <p:spPr>
-          <a:xfrm flipV="1">
-            <a:off x="2884791" y="3405845"/>
-            <a:ext cx="769998" cy="420118"/>
-          </a:xfrm>
-          <a:prstGeom prst="line">
-            <a:avLst/>
-          </a:prstGeom>
-          <a:ln w="38100">
-            <a:solidFill>
-              <a:srgbClr val="AAAAAA"/>
-            </a:solidFill>
-          </a:ln>
-        </p:spPr>
-        <p:style>
-          <a:lnRef idx="1">
-            <a:schemeClr val="accent1"/>
-          </a:lnRef>
-          <a:fillRef idx="0">
-            <a:schemeClr val="accent1"/>
-          </a:fillRef>
-          <a:effectRef idx="0">
-            <a:schemeClr val="accent1"/>
-          </a:effectRef>
-          <a:fontRef idx="minor">
-            <a:schemeClr val="tx1"/>
-          </a:fontRef>
-        </p:style>
-      </p:cxnSp>
-      <p:cxnSp>
-        <p:nvCxnSpPr>
-          <p:cNvPr id="80" name="Straight Connector 79">
-            <a:extLst>
-              <a:ext uri="{FF2B5EF4-FFF2-40B4-BE49-F238E27FC236}">
-                <a16:creationId xmlns:a16="http://schemas.microsoft.com/office/drawing/2014/main" id="{2AA04C5F-E7F4-32AE-FC13-2EB4A200AE4D}"/>
-              </a:ext>
-            </a:extLst>
-          </p:cNvPr>
-          <p:cNvCxnSpPr>
-            <a:cxnSpLocks/>
-            <a:stCxn id="86" idx="2"/>
-            <a:endCxn id="87" idx="0"/>
-          </p:cNvCxnSpPr>
-          <p:nvPr/>
-        </p:nvCxnSpPr>
-        <p:spPr>
-          <a:xfrm>
-            <a:off x="8177213" y="3405845"/>
-            <a:ext cx="531771" cy="420118"/>
-          </a:xfrm>
-          <a:prstGeom prst="line">
-            <a:avLst/>
-          </a:prstGeom>
-          <a:ln w="38100">
-            <a:solidFill>
-              <a:srgbClr val="AAAAAA"/>
-            </a:solidFill>
-          </a:ln>
-        </p:spPr>
-        <p:style>
-          <a:lnRef idx="1">
-            <a:schemeClr val="accent1"/>
-          </a:lnRef>
-          <a:fillRef idx="0">
-            <a:schemeClr val="accent1"/>
-          </a:fillRef>
-          <a:effectRef idx="0">
-            <a:schemeClr val="accent1"/>
-          </a:effectRef>
-          <a:fontRef idx="minor">
-            <a:schemeClr val="tx1"/>
-          </a:fontRef>
-        </p:style>
-      </p:cxnSp>
-      <p:sp>
-        <p:nvSpPr>
-          <p:cNvPr id="81" name="Rectangle 80">
-            <a:extLst>
-              <a:ext uri="{FF2B5EF4-FFF2-40B4-BE49-F238E27FC236}">
-                <a16:creationId xmlns:a16="http://schemas.microsoft.com/office/drawing/2014/main" id="{7CE02771-8B46-D850-868D-AF850E6DC330}"/>
-              </a:ext>
-            </a:extLst>
-          </p:cNvPr>
-          <p:cNvSpPr/>
-          <p:nvPr/>
-        </p:nvSpPr>
-        <p:spPr>
-          <a:xfrm>
-            <a:off x="3936001" y="2865845"/>
-            <a:ext cx="540000" cy="540000"/>
-          </a:xfrm>
-          <a:prstGeom prst="rect">
-            <a:avLst/>
-          </a:prstGeom>
-          <a:solidFill>
-            <a:srgbClr val="6AB5FF"/>
-          </a:solidFill>
-        </p:spPr>
-        <p:style>
-          <a:lnRef idx="2">
-            <a:schemeClr val="accent1">
-              <a:shade val="15000"/>
-            </a:schemeClr>
-          </a:lnRef>
-          <a:fillRef idx="1">
-            <a:schemeClr val="accent1"/>
-          </a:fillRef>
-          <a:effectRef idx="0">
-            <a:schemeClr val="accent1"/>
-          </a:effectRef>
-          <a:fontRef idx="minor">
-            <a:schemeClr val="lt1"/>
-          </a:fontRef>
-        </p:style>
-        <p:txBody>
-          <a:bodyPr rtlCol="0" anchor="ctr"/>
-          <a:lstStyle/>
-          <a:p>
-            <a:pPr algn="ctr"/>
-            <a:r>
-              <a:rPr lang="en-US" sz="1200" b="1" dirty="0"/>
-              <a:t>Value</a:t>
-            </a:r>
-          </a:p>
-        </p:txBody>
-      </p:sp>
-      <p:sp>
-        <p:nvSpPr>
-          <p:cNvPr id="82" name="Rectangle 81">
-            <a:extLst>
-              <a:ext uri="{FF2B5EF4-FFF2-40B4-BE49-F238E27FC236}">
-                <a16:creationId xmlns:a16="http://schemas.microsoft.com/office/drawing/2014/main" id="{EA6B1BBB-CE61-A267-E9EB-0E6821F2AEE7}"/>
-              </a:ext>
-            </a:extLst>
-          </p:cNvPr>
-          <p:cNvSpPr/>
-          <p:nvPr/>
-        </p:nvSpPr>
-        <p:spPr>
-          <a:xfrm>
-            <a:off x="3390395" y="2865845"/>
-            <a:ext cx="540000" cy="540000"/>
-          </a:xfrm>
-          <a:prstGeom prst="rect">
-            <a:avLst/>
-          </a:prstGeom>
-          <a:solidFill>
-            <a:schemeClr val="accent5">
-              <a:lumMod val="50000"/>
-            </a:schemeClr>
-          </a:solidFill>
-        </p:spPr>
-        <p:style>
-          <a:lnRef idx="2">
-            <a:schemeClr val="accent1">
-              <a:shade val="15000"/>
-            </a:schemeClr>
-          </a:lnRef>
-          <a:fillRef idx="1">
-            <a:schemeClr val="accent1"/>
-          </a:fillRef>
-          <a:effectRef idx="0">
-            <a:schemeClr val="accent1"/>
-          </a:effectRef>
-          <a:fontRef idx="minor">
-            <a:schemeClr val="lt1"/>
-          </a:fontRef>
-        </p:style>
-        <p:txBody>
-          <a:bodyPr rtlCol="0" anchor="ctr"/>
-          <a:lstStyle/>
-          <a:p>
-            <a:pPr algn="ctr"/>
-            <a:r>
-              <a:rPr lang="en-US" sz="900" b="1" dirty="0"/>
-              <a:t>Left Pointer</a:t>
-            </a:r>
-          </a:p>
-        </p:txBody>
-      </p:sp>
-      <p:sp>
-        <p:nvSpPr>
-          <p:cNvPr id="83" name="Rectangle 82">
-            <a:extLst>
-              <a:ext uri="{FF2B5EF4-FFF2-40B4-BE49-F238E27FC236}">
-                <a16:creationId xmlns:a16="http://schemas.microsoft.com/office/drawing/2014/main" id="{6FB5394D-667B-9B98-CEF0-4067AAE74213}"/>
-              </a:ext>
-            </a:extLst>
-          </p:cNvPr>
-          <p:cNvSpPr/>
-          <p:nvPr/>
-        </p:nvSpPr>
-        <p:spPr>
-          <a:xfrm>
-            <a:off x="4476001" y="2865845"/>
-            <a:ext cx="540000" cy="540000"/>
-          </a:xfrm>
-          <a:prstGeom prst="rect">
-            <a:avLst/>
-          </a:prstGeom>
-          <a:solidFill>
-            <a:schemeClr val="accent5">
-              <a:lumMod val="50000"/>
-            </a:schemeClr>
-          </a:solidFill>
-        </p:spPr>
-        <p:style>
-          <a:lnRef idx="2">
-            <a:schemeClr val="accent1">
-              <a:shade val="15000"/>
-            </a:schemeClr>
-          </a:lnRef>
-          <a:fillRef idx="1">
-            <a:schemeClr val="accent1"/>
-          </a:fillRef>
-          <a:effectRef idx="0">
-            <a:schemeClr val="accent1"/>
-          </a:effectRef>
-          <a:fontRef idx="minor">
-            <a:schemeClr val="lt1"/>
-          </a:fontRef>
-        </p:style>
-        <p:txBody>
-          <a:bodyPr rtlCol="0" anchor="ctr"/>
-          <a:lstStyle/>
-          <a:p>
-            <a:pPr algn="ctr"/>
-            <a:r>
-              <a:rPr lang="en-US" sz="900" b="1" dirty="0"/>
-              <a:t>Right</a:t>
-            </a:r>
-          </a:p>
-          <a:p>
-            <a:pPr algn="ctr"/>
-            <a:r>
-              <a:rPr lang="en-US" sz="900" b="1" dirty="0"/>
-              <a:t>Pointer</a:t>
-            </a:r>
-          </a:p>
-        </p:txBody>
-      </p:sp>
-      <p:sp>
-        <p:nvSpPr>
-          <p:cNvPr id="84" name="Rectangle 83">
-            <a:extLst>
-              <a:ext uri="{FF2B5EF4-FFF2-40B4-BE49-F238E27FC236}">
-                <a16:creationId xmlns:a16="http://schemas.microsoft.com/office/drawing/2014/main" id="{8B4024BB-E862-81BB-61DD-2264DFA22725}"/>
-              </a:ext>
-            </a:extLst>
-          </p:cNvPr>
-          <p:cNvSpPr/>
-          <p:nvPr/>
-        </p:nvSpPr>
-        <p:spPr>
-          <a:xfrm>
-            <a:off x="7367213" y="2865845"/>
-            <a:ext cx="540000" cy="540000"/>
-          </a:xfrm>
-          <a:prstGeom prst="rect">
-            <a:avLst/>
-          </a:prstGeom>
-          <a:solidFill>
-            <a:srgbClr val="6AB5FF"/>
-          </a:solidFill>
-        </p:spPr>
-        <p:style>
-          <a:lnRef idx="2">
-            <a:schemeClr val="accent1">
-              <a:shade val="15000"/>
-            </a:schemeClr>
-          </a:lnRef>
-          <a:fillRef idx="1">
-            <a:schemeClr val="accent1"/>
-          </a:fillRef>
-          <a:effectRef idx="0">
-            <a:schemeClr val="accent1"/>
-          </a:effectRef>
-          <a:fontRef idx="minor">
-            <a:schemeClr val="lt1"/>
-          </a:fontRef>
-        </p:style>
-        <p:txBody>
-          <a:bodyPr rtlCol="0" anchor="ctr"/>
-          <a:lstStyle/>
-          <a:p>
-            <a:pPr algn="ctr"/>
-            <a:r>
-              <a:rPr lang="en-US" sz="1200" b="1" dirty="0"/>
-              <a:t>Value</a:t>
-            </a:r>
-          </a:p>
-        </p:txBody>
-      </p:sp>
-      <p:sp>
-        <p:nvSpPr>
-          <p:cNvPr id="85" name="Rectangle 84">
-            <a:extLst>
-              <a:ext uri="{FF2B5EF4-FFF2-40B4-BE49-F238E27FC236}">
-                <a16:creationId xmlns:a16="http://schemas.microsoft.com/office/drawing/2014/main" id="{538ED40E-C8CC-759A-0FF8-211CF22AC6AF}"/>
-              </a:ext>
-            </a:extLst>
-          </p:cNvPr>
-          <p:cNvSpPr/>
-          <p:nvPr/>
-        </p:nvSpPr>
-        <p:spPr>
-          <a:xfrm>
-            <a:off x="6827213" y="2865845"/>
-            <a:ext cx="540000" cy="540000"/>
-          </a:xfrm>
-          <a:prstGeom prst="rect">
-            <a:avLst/>
-          </a:prstGeom>
-          <a:solidFill>
-            <a:schemeClr val="accent5">
-              <a:lumMod val="50000"/>
-            </a:schemeClr>
-          </a:solidFill>
-        </p:spPr>
-        <p:style>
-          <a:lnRef idx="2">
-            <a:schemeClr val="accent1">
-              <a:shade val="15000"/>
-            </a:schemeClr>
-          </a:lnRef>
-          <a:fillRef idx="1">
-            <a:schemeClr val="accent1"/>
-          </a:fillRef>
-          <a:effectRef idx="0">
-            <a:schemeClr val="accent1"/>
-          </a:effectRef>
-          <a:fontRef idx="minor">
-            <a:schemeClr val="lt1"/>
-          </a:fontRef>
-        </p:style>
-        <p:txBody>
-          <a:bodyPr rtlCol="0" anchor="ctr"/>
-          <a:lstStyle/>
-          <a:p>
-            <a:pPr algn="ctr"/>
-            <a:r>
-              <a:rPr lang="en-US" sz="900" b="1" dirty="0"/>
-              <a:t>Left Pointer</a:t>
-            </a:r>
-          </a:p>
-        </p:txBody>
-      </p:sp>
-      <p:sp>
-        <p:nvSpPr>
-          <p:cNvPr id="86" name="Rectangle 85">
-            <a:extLst>
-              <a:ext uri="{FF2B5EF4-FFF2-40B4-BE49-F238E27FC236}">
-                <a16:creationId xmlns:a16="http://schemas.microsoft.com/office/drawing/2014/main" id="{69813463-08CE-395C-AFF8-7294B566D184}"/>
-              </a:ext>
-            </a:extLst>
-          </p:cNvPr>
-          <p:cNvSpPr/>
-          <p:nvPr/>
-        </p:nvSpPr>
-        <p:spPr>
-          <a:xfrm>
-            <a:off x="7907213" y="2865845"/>
-            <a:ext cx="540000" cy="540000"/>
-          </a:xfrm>
-          <a:prstGeom prst="rect">
-            <a:avLst/>
-          </a:prstGeom>
-          <a:solidFill>
-            <a:schemeClr val="accent5">
-              <a:lumMod val="50000"/>
-            </a:schemeClr>
-          </a:solidFill>
-        </p:spPr>
-        <p:style>
-          <a:lnRef idx="2">
-            <a:schemeClr val="accent1">
-              <a:shade val="15000"/>
-            </a:schemeClr>
-          </a:lnRef>
-          <a:fillRef idx="1">
-            <a:schemeClr val="accent1"/>
-          </a:fillRef>
-          <a:effectRef idx="0">
-            <a:schemeClr val="accent1"/>
-          </a:effectRef>
-          <a:fontRef idx="minor">
-            <a:schemeClr val="lt1"/>
-          </a:fontRef>
-        </p:style>
-        <p:txBody>
-          <a:bodyPr rtlCol="0" anchor="ctr"/>
-          <a:lstStyle/>
-          <a:p>
-            <a:pPr algn="ctr"/>
-            <a:r>
-              <a:rPr lang="en-US" sz="900" b="1" dirty="0"/>
-              <a:t>Right</a:t>
-            </a:r>
-          </a:p>
-          <a:p>
-            <a:pPr algn="ctr"/>
-            <a:r>
-              <a:rPr lang="en-US" sz="900" b="1" dirty="0"/>
-              <a:t>Pointer</a:t>
-            </a:r>
-          </a:p>
-        </p:txBody>
-      </p:sp>
-      <p:sp>
-        <p:nvSpPr>
-          <p:cNvPr id="87" name="Rectangle 86">
-            <a:extLst>
-              <a:ext uri="{FF2B5EF4-FFF2-40B4-BE49-F238E27FC236}">
-                <a16:creationId xmlns:a16="http://schemas.microsoft.com/office/drawing/2014/main" id="{F7026A71-666B-5DA4-B700-9FF7BE81204B}"/>
-              </a:ext>
-            </a:extLst>
-          </p:cNvPr>
-          <p:cNvSpPr/>
-          <p:nvPr/>
-        </p:nvSpPr>
-        <p:spPr>
-          <a:xfrm>
-            <a:off x="8438984" y="3825963"/>
-            <a:ext cx="540000" cy="540000"/>
-          </a:xfrm>
-          <a:prstGeom prst="rect">
-            <a:avLst/>
-          </a:prstGeom>
-          <a:solidFill>
-            <a:srgbClr val="6AB5FF"/>
-          </a:solidFill>
-        </p:spPr>
-        <p:style>
-          <a:lnRef idx="2">
-            <a:schemeClr val="accent1">
-              <a:shade val="15000"/>
-            </a:schemeClr>
-          </a:lnRef>
-          <a:fillRef idx="1">
-            <a:schemeClr val="accent1"/>
-          </a:fillRef>
-          <a:effectRef idx="0">
-            <a:schemeClr val="accent1"/>
-          </a:effectRef>
-          <a:fontRef idx="minor">
-            <a:schemeClr val="lt1"/>
-          </a:fontRef>
-        </p:style>
-        <p:txBody>
-          <a:bodyPr rtlCol="0" anchor="ctr"/>
-          <a:lstStyle/>
-          <a:p>
-            <a:pPr algn="ctr"/>
-            <a:r>
-              <a:rPr lang="en-US" sz="1200" b="1" dirty="0"/>
-              <a:t>Value</a:t>
-            </a:r>
-          </a:p>
-        </p:txBody>
-      </p:sp>
-      <p:sp>
-        <p:nvSpPr>
-          <p:cNvPr id="88" name="Rectangle 87">
-            <a:extLst>
-              <a:ext uri="{FF2B5EF4-FFF2-40B4-BE49-F238E27FC236}">
-                <a16:creationId xmlns:a16="http://schemas.microsoft.com/office/drawing/2014/main" id="{9FAC2B21-A147-E092-5358-1B29D9AD08F0}"/>
-              </a:ext>
-            </a:extLst>
-          </p:cNvPr>
-          <p:cNvSpPr/>
-          <p:nvPr/>
-        </p:nvSpPr>
-        <p:spPr>
-          <a:xfrm>
-            <a:off x="3384789" y="2865845"/>
-            <a:ext cx="540000" cy="540000"/>
-          </a:xfrm>
-          <a:prstGeom prst="rect">
-            <a:avLst/>
-          </a:prstGeom>
-          <a:solidFill>
-            <a:schemeClr val="accent5">
-              <a:lumMod val="50000"/>
-            </a:schemeClr>
-          </a:solidFill>
-        </p:spPr>
-        <p:style>
-          <a:lnRef idx="2">
-            <a:schemeClr val="accent1">
-              <a:shade val="15000"/>
-            </a:schemeClr>
-          </a:lnRef>
-          <a:fillRef idx="1">
-            <a:schemeClr val="accent1"/>
-          </a:fillRef>
-          <a:effectRef idx="0">
-            <a:schemeClr val="accent1"/>
-          </a:effectRef>
-          <a:fontRef idx="minor">
-            <a:schemeClr val="lt1"/>
-          </a:fontRef>
-        </p:style>
-        <p:txBody>
-          <a:bodyPr rtlCol="0" anchor="ctr"/>
-          <a:lstStyle/>
-          <a:p>
-            <a:pPr algn="ctr"/>
-            <a:r>
-              <a:rPr lang="en-US" sz="900" b="1" dirty="0"/>
-              <a:t>Left Pointer</a:t>
-            </a:r>
-          </a:p>
-        </p:txBody>
-      </p:sp>
-      <p:sp>
-        <p:nvSpPr>
-          <p:cNvPr id="89" name="Rectangle 88">
-            <a:extLst>
-              <a:ext uri="{FF2B5EF4-FFF2-40B4-BE49-F238E27FC236}">
-                <a16:creationId xmlns:a16="http://schemas.microsoft.com/office/drawing/2014/main" id="{0B359543-5504-DD22-0386-4F6D60B385C1}"/>
-              </a:ext>
-            </a:extLst>
-          </p:cNvPr>
-          <p:cNvSpPr/>
-          <p:nvPr/>
-        </p:nvSpPr>
-        <p:spPr>
-          <a:xfrm>
-            <a:off x="8978984" y="3825963"/>
-            <a:ext cx="540000" cy="540000"/>
-          </a:xfrm>
-          <a:prstGeom prst="rect">
-            <a:avLst/>
-          </a:prstGeom>
-          <a:solidFill>
-            <a:schemeClr val="accent5">
-              <a:lumMod val="50000"/>
-            </a:schemeClr>
-          </a:solidFill>
-        </p:spPr>
-        <p:style>
-          <a:lnRef idx="2">
-            <a:schemeClr val="accent1">
-              <a:shade val="15000"/>
-            </a:schemeClr>
-          </a:lnRef>
-          <a:fillRef idx="1">
-            <a:schemeClr val="accent1"/>
-          </a:fillRef>
-          <a:effectRef idx="0">
-            <a:schemeClr val="accent1"/>
-          </a:effectRef>
-          <a:fontRef idx="minor">
-            <a:schemeClr val="lt1"/>
-          </a:fontRef>
-        </p:style>
-        <p:txBody>
-          <a:bodyPr rtlCol="0" anchor="ctr"/>
-          <a:lstStyle/>
-          <a:p>
-            <a:pPr algn="ctr"/>
-            <a:r>
-              <a:rPr lang="en-US" sz="900" b="1" dirty="0"/>
-              <a:t>Right</a:t>
-            </a:r>
-          </a:p>
-          <a:p>
-            <a:pPr algn="ctr"/>
-            <a:r>
-              <a:rPr lang="en-US" sz="900" b="1" dirty="0"/>
-              <a:t>Pointer</a:t>
-            </a:r>
-          </a:p>
-        </p:txBody>
-      </p:sp>
-      <p:sp>
-        <p:nvSpPr>
-          <p:cNvPr id="90" name="Rectangle 89">
-            <a:extLst>
-              <a:ext uri="{FF2B5EF4-FFF2-40B4-BE49-F238E27FC236}">
-                <a16:creationId xmlns:a16="http://schemas.microsoft.com/office/drawing/2014/main" id="{6153B788-DFA0-137D-F656-04DDFE0194B1}"/>
-              </a:ext>
-            </a:extLst>
-          </p:cNvPr>
-          <p:cNvSpPr/>
-          <p:nvPr/>
-        </p:nvSpPr>
-        <p:spPr>
-          <a:xfrm>
-            <a:off x="2614791" y="3825963"/>
-            <a:ext cx="540000" cy="540000"/>
-          </a:xfrm>
-          <a:prstGeom prst="rect">
-            <a:avLst/>
-          </a:prstGeom>
-          <a:solidFill>
-            <a:srgbClr val="6AB5FF"/>
-          </a:solidFill>
-        </p:spPr>
-        <p:style>
-          <a:lnRef idx="2">
-            <a:schemeClr val="accent1">
-              <a:shade val="15000"/>
-            </a:schemeClr>
-          </a:lnRef>
-          <a:fillRef idx="1">
-            <a:schemeClr val="accent1"/>
-          </a:fillRef>
-          <a:effectRef idx="0">
-            <a:schemeClr val="accent1"/>
-          </a:effectRef>
-          <a:fontRef idx="minor">
-            <a:schemeClr val="lt1"/>
-          </a:fontRef>
-        </p:style>
-        <p:txBody>
-          <a:bodyPr rtlCol="0" anchor="ctr"/>
-          <a:lstStyle/>
-          <a:p>
-            <a:pPr algn="ctr"/>
-            <a:r>
-              <a:rPr lang="en-US" sz="1200" b="1" dirty="0"/>
-              <a:t>Value</a:t>
-            </a:r>
-          </a:p>
-        </p:txBody>
-      </p:sp>
-      <p:sp>
-        <p:nvSpPr>
-          <p:cNvPr id="91" name="Rectangle 90">
-            <a:extLst>
-              <a:ext uri="{FF2B5EF4-FFF2-40B4-BE49-F238E27FC236}">
-                <a16:creationId xmlns:a16="http://schemas.microsoft.com/office/drawing/2014/main" id="{006A7970-24C8-7343-33C8-BF0A80B86D05}"/>
-              </a:ext>
-            </a:extLst>
-          </p:cNvPr>
-          <p:cNvSpPr/>
-          <p:nvPr/>
-        </p:nvSpPr>
-        <p:spPr>
-          <a:xfrm>
-            <a:off x="2074791" y="3825963"/>
-            <a:ext cx="540000" cy="540000"/>
-          </a:xfrm>
-          <a:prstGeom prst="rect">
-            <a:avLst/>
-          </a:prstGeom>
-          <a:solidFill>
-            <a:schemeClr val="accent5">
-              <a:lumMod val="50000"/>
-            </a:schemeClr>
-          </a:solidFill>
-        </p:spPr>
-        <p:style>
-          <a:lnRef idx="2">
-            <a:schemeClr val="accent1">
-              <a:shade val="15000"/>
-            </a:schemeClr>
-          </a:lnRef>
-          <a:fillRef idx="1">
-            <a:schemeClr val="accent1"/>
-          </a:fillRef>
-          <a:effectRef idx="0">
-            <a:schemeClr val="accent1"/>
-          </a:effectRef>
-          <a:fontRef idx="minor">
-            <a:schemeClr val="lt1"/>
-          </a:fontRef>
-        </p:style>
-        <p:txBody>
-          <a:bodyPr rtlCol="0" anchor="ctr"/>
-          <a:lstStyle/>
-          <a:p>
-            <a:pPr algn="ctr"/>
-            <a:r>
-              <a:rPr lang="en-US" sz="900" b="1" dirty="0"/>
-              <a:t>Left Pointer</a:t>
-            </a:r>
-          </a:p>
-        </p:txBody>
-      </p:sp>
-      <p:sp>
-        <p:nvSpPr>
-          <p:cNvPr id="92" name="Rectangle 91">
-            <a:extLst>
-              <a:ext uri="{FF2B5EF4-FFF2-40B4-BE49-F238E27FC236}">
-                <a16:creationId xmlns:a16="http://schemas.microsoft.com/office/drawing/2014/main" id="{5BA15602-1E89-DCB8-B0B3-3AF10120C860}"/>
-              </a:ext>
-            </a:extLst>
-          </p:cNvPr>
-          <p:cNvSpPr/>
-          <p:nvPr/>
-        </p:nvSpPr>
-        <p:spPr>
-          <a:xfrm>
-            <a:off x="3154791" y="3825963"/>
-            <a:ext cx="540000" cy="540000"/>
-          </a:xfrm>
-          <a:prstGeom prst="rect">
-            <a:avLst/>
-          </a:prstGeom>
-          <a:solidFill>
-            <a:schemeClr val="accent5">
-              <a:lumMod val="50000"/>
-            </a:schemeClr>
-          </a:solidFill>
-        </p:spPr>
-        <p:style>
-          <a:lnRef idx="2">
-            <a:schemeClr val="accent1">
-              <a:shade val="15000"/>
-            </a:schemeClr>
-          </a:lnRef>
-          <a:fillRef idx="1">
-            <a:schemeClr val="accent1"/>
-          </a:fillRef>
-          <a:effectRef idx="0">
-            <a:schemeClr val="accent1"/>
-          </a:effectRef>
-          <a:fontRef idx="minor">
-            <a:schemeClr val="lt1"/>
-          </a:fontRef>
-        </p:style>
-        <p:txBody>
-          <a:bodyPr rtlCol="0" anchor="ctr"/>
-          <a:lstStyle/>
-          <a:p>
-            <a:pPr algn="ctr"/>
-            <a:r>
-              <a:rPr lang="en-US" sz="900" b="1" dirty="0"/>
-              <a:t>Right</a:t>
-            </a:r>
-          </a:p>
-          <a:p>
-            <a:pPr algn="ctr"/>
-            <a:r>
-              <a:rPr lang="en-US" sz="900" b="1" dirty="0"/>
-              <a:t>Pointer</a:t>
-            </a:r>
-          </a:p>
-        </p:txBody>
-      </p:sp>
-      <p:sp>
-        <p:nvSpPr>
-          <p:cNvPr id="2" name="TextBox 1">
-            <a:extLst>
-              <a:ext uri="{FF2B5EF4-FFF2-40B4-BE49-F238E27FC236}">
-                <a16:creationId xmlns:a16="http://schemas.microsoft.com/office/drawing/2014/main" id="{62757CFA-06BE-5E89-FB7A-C7A11E2FF38A}"/>
+      <p:sp>
+        <p:nvSpPr>
+          <p:cNvPr id="95" name="TextBox 94">
+            <a:extLst>
+              <a:ext uri="{FF2B5EF4-FFF2-40B4-BE49-F238E27FC236}">
+                <a16:creationId xmlns:a16="http://schemas.microsoft.com/office/drawing/2014/main" id="{DC577992-DB1B-F2C7-097E-925D799D9F55}"/>
               </a:ext>
             </a:extLst>
           </p:cNvPr>
@@ -42041,276 +42307,10 @@
           </a:p>
         </p:txBody>
       </p:sp>
-      <p:sp>
-        <p:nvSpPr>
-          <p:cNvPr id="11" name="Rectangle 10">
-            <a:extLst>
-              <a:ext uri="{FF2B5EF4-FFF2-40B4-BE49-F238E27FC236}">
-                <a16:creationId xmlns:a16="http://schemas.microsoft.com/office/drawing/2014/main" id="{6B726CA4-E7AE-8BA0-FA50-67C26B7F2BC5}"/>
-              </a:ext>
-            </a:extLst>
-          </p:cNvPr>
-          <p:cNvSpPr/>
-          <p:nvPr/>
-        </p:nvSpPr>
-        <p:spPr>
-          <a:xfrm>
-            <a:off x="7907213" y="3825963"/>
-            <a:ext cx="540000" cy="540000"/>
-          </a:xfrm>
-          <a:prstGeom prst="rect">
-            <a:avLst/>
-          </a:prstGeom>
-          <a:solidFill>
-            <a:schemeClr val="accent5">
-              <a:lumMod val="50000"/>
-            </a:schemeClr>
-          </a:solidFill>
-        </p:spPr>
-        <p:style>
-          <a:lnRef idx="2">
-            <a:schemeClr val="accent1">
-              <a:shade val="15000"/>
-            </a:schemeClr>
-          </a:lnRef>
-          <a:fillRef idx="1">
-            <a:schemeClr val="accent1"/>
-          </a:fillRef>
-          <a:effectRef idx="0">
-            <a:schemeClr val="accent1"/>
-          </a:effectRef>
-          <a:fontRef idx="minor">
-            <a:schemeClr val="lt1"/>
-          </a:fontRef>
-        </p:style>
-        <p:txBody>
-          <a:bodyPr rtlCol="0" anchor="ctr"/>
-          <a:lstStyle/>
-          <a:p>
-            <a:pPr algn="ctr"/>
-            <a:r>
-              <a:rPr lang="en-US" sz="900" b="1" dirty="0"/>
-              <a:t>Left Pointer</a:t>
-            </a:r>
-          </a:p>
-        </p:txBody>
-      </p:sp>
-      <p:sp>
-        <p:nvSpPr>
-          <p:cNvPr id="12" name="Rectangle 11">
-            <a:extLst>
-              <a:ext uri="{FF2B5EF4-FFF2-40B4-BE49-F238E27FC236}">
-                <a16:creationId xmlns:a16="http://schemas.microsoft.com/office/drawing/2014/main" id="{EEAF8C38-CF79-6340-E4CB-0B618932233E}"/>
-              </a:ext>
-            </a:extLst>
-          </p:cNvPr>
-          <p:cNvSpPr/>
-          <p:nvPr/>
-        </p:nvSpPr>
-        <p:spPr>
-          <a:xfrm>
-            <a:off x="5006888" y="3824961"/>
-            <a:ext cx="540000" cy="540000"/>
-          </a:xfrm>
-          <a:prstGeom prst="rect">
-            <a:avLst/>
-          </a:prstGeom>
-          <a:solidFill>
-            <a:srgbClr val="6AB5FF"/>
-          </a:solidFill>
-        </p:spPr>
-        <p:style>
-          <a:lnRef idx="2">
-            <a:schemeClr val="accent1">
-              <a:shade val="15000"/>
-            </a:schemeClr>
-          </a:lnRef>
-          <a:fillRef idx="1">
-            <a:schemeClr val="accent1"/>
-          </a:fillRef>
-          <a:effectRef idx="0">
-            <a:schemeClr val="accent1"/>
-          </a:effectRef>
-          <a:fontRef idx="minor">
-            <a:schemeClr val="lt1"/>
-          </a:fontRef>
-        </p:style>
-        <p:txBody>
-          <a:bodyPr rtlCol="0" anchor="ctr"/>
-          <a:lstStyle/>
-          <a:p>
-            <a:pPr algn="ctr"/>
-            <a:r>
-              <a:rPr lang="en-US" sz="1200" b="1" dirty="0"/>
-              <a:t>Value</a:t>
-            </a:r>
-          </a:p>
-        </p:txBody>
-      </p:sp>
-      <p:sp>
-        <p:nvSpPr>
-          <p:cNvPr id="13" name="Rectangle 12">
-            <a:extLst>
-              <a:ext uri="{FF2B5EF4-FFF2-40B4-BE49-F238E27FC236}">
-                <a16:creationId xmlns:a16="http://schemas.microsoft.com/office/drawing/2014/main" id="{F93E0D11-54E8-C4AD-4CF5-3BB2D1A5914C}"/>
-              </a:ext>
-            </a:extLst>
-          </p:cNvPr>
-          <p:cNvSpPr/>
-          <p:nvPr/>
-        </p:nvSpPr>
-        <p:spPr>
-          <a:xfrm>
-            <a:off x="5546888" y="3824961"/>
-            <a:ext cx="540000" cy="540000"/>
-          </a:xfrm>
-          <a:prstGeom prst="rect">
-            <a:avLst/>
-          </a:prstGeom>
-          <a:solidFill>
-            <a:schemeClr val="accent5">
-              <a:lumMod val="50000"/>
-            </a:schemeClr>
-          </a:solidFill>
-        </p:spPr>
-        <p:style>
-          <a:lnRef idx="2">
-            <a:schemeClr val="accent1">
-              <a:shade val="15000"/>
-            </a:schemeClr>
-          </a:lnRef>
-          <a:fillRef idx="1">
-            <a:schemeClr val="accent1"/>
-          </a:fillRef>
-          <a:effectRef idx="0">
-            <a:schemeClr val="accent1"/>
-          </a:effectRef>
-          <a:fontRef idx="minor">
-            <a:schemeClr val="lt1"/>
-          </a:fontRef>
-        </p:style>
-        <p:txBody>
-          <a:bodyPr rtlCol="0" anchor="ctr"/>
-          <a:lstStyle/>
-          <a:p>
-            <a:pPr algn="ctr"/>
-            <a:r>
-              <a:rPr lang="en-US" sz="900" b="1" dirty="0"/>
-              <a:t>Right</a:t>
-            </a:r>
-          </a:p>
-          <a:p>
-            <a:pPr algn="ctr"/>
-            <a:r>
-              <a:rPr lang="en-US" sz="900" b="1" dirty="0"/>
-              <a:t>Pointer</a:t>
-            </a:r>
-          </a:p>
-        </p:txBody>
-      </p:sp>
-      <p:sp>
-        <p:nvSpPr>
-          <p:cNvPr id="14" name="Rectangle 13">
-            <a:extLst>
-              <a:ext uri="{FF2B5EF4-FFF2-40B4-BE49-F238E27FC236}">
-                <a16:creationId xmlns:a16="http://schemas.microsoft.com/office/drawing/2014/main" id="{7B72D703-F8E7-007F-4212-07833D9BA806}"/>
-              </a:ext>
-            </a:extLst>
-          </p:cNvPr>
-          <p:cNvSpPr/>
-          <p:nvPr/>
-        </p:nvSpPr>
-        <p:spPr>
-          <a:xfrm>
-            <a:off x="4475117" y="3824961"/>
-            <a:ext cx="540000" cy="540000"/>
-          </a:xfrm>
-          <a:prstGeom prst="rect">
-            <a:avLst/>
-          </a:prstGeom>
-          <a:solidFill>
-            <a:schemeClr val="accent5">
-              <a:lumMod val="50000"/>
-            </a:schemeClr>
-          </a:solidFill>
-        </p:spPr>
-        <p:style>
-          <a:lnRef idx="2">
-            <a:schemeClr val="accent1">
-              <a:shade val="15000"/>
-            </a:schemeClr>
-          </a:lnRef>
-          <a:fillRef idx="1">
-            <a:schemeClr val="accent1"/>
-          </a:fillRef>
-          <a:effectRef idx="0">
-            <a:schemeClr val="accent1"/>
-          </a:effectRef>
-          <a:fontRef idx="minor">
-            <a:schemeClr val="lt1"/>
-          </a:fontRef>
-        </p:style>
-        <p:txBody>
-          <a:bodyPr rtlCol="0" anchor="ctr"/>
-          <a:lstStyle/>
-          <a:p>
-            <a:pPr algn="ctr"/>
-            <a:r>
-              <a:rPr lang="en-US" sz="900" b="1" dirty="0"/>
-              <a:t>Left Pointer</a:t>
-            </a:r>
-          </a:p>
-        </p:txBody>
-      </p:sp>
-      <p:cxnSp>
-        <p:nvCxnSpPr>
-          <p:cNvPr id="15" name="Straight Connector 14">
-            <a:extLst>
-              <a:ext uri="{FF2B5EF4-FFF2-40B4-BE49-F238E27FC236}">
-                <a16:creationId xmlns:a16="http://schemas.microsoft.com/office/drawing/2014/main" id="{2A5F6DC8-128C-A596-4819-37B438B4DF5F}"/>
-              </a:ext>
-            </a:extLst>
-          </p:cNvPr>
-          <p:cNvCxnSpPr>
-            <a:cxnSpLocks/>
-            <a:stCxn id="12" idx="0"/>
-            <a:endCxn id="83" idx="2"/>
-          </p:cNvCxnSpPr>
-          <p:nvPr/>
-        </p:nvCxnSpPr>
-        <p:spPr>
-          <a:xfrm flipH="1" flipV="1">
-            <a:off x="4746001" y="3405845"/>
-            <a:ext cx="530887" cy="419116"/>
-          </a:xfrm>
-          <a:prstGeom prst="line">
-            <a:avLst/>
-          </a:prstGeom>
-          <a:ln w="38100">
-            <a:solidFill>
-              <a:srgbClr val="AAAAAA"/>
-            </a:solidFill>
-          </a:ln>
-        </p:spPr>
-        <p:style>
-          <a:lnRef idx="1">
-            <a:schemeClr val="accent1"/>
-          </a:lnRef>
-          <a:fillRef idx="0">
-            <a:schemeClr val="accent1"/>
-          </a:fillRef>
-          <a:effectRef idx="0">
-            <a:schemeClr val="accent1"/>
-          </a:effectRef>
-          <a:fontRef idx="minor">
-            <a:schemeClr val="tx1"/>
-          </a:fontRef>
-        </p:style>
-      </p:cxnSp>
     </p:spTree>
     <p:extLst>
       <p:ext uri="{BB962C8B-B14F-4D97-AF65-F5344CB8AC3E}">
-        <p14:creationId xmlns:p14="http://schemas.microsoft.com/office/powerpoint/2010/main" val="3529036991"/>
+        <p14:creationId xmlns:p14="http://schemas.microsoft.com/office/powerpoint/2010/main" val="2301016541"/>
       </p:ext>
     </p:extLst>
   </p:cSld>

</xml_diff>